<commit_message>
feat: prepare 4.4 release docs, deck, and Linux CI gates
Unblock PR #243: compile with -fPIC, add `make nanoc` for the bench job,
accept i18n drafts that point at English generated guides, and drop the
utf8proc apt packages that 241 already removed on main. Document 4.1–4.4
as one v4.4.0 tag, rebuild the developer deck, and draft the LinkedIn post.

Related to task_7b6e8957be5b4abf8b0ea4751fd9b635.

Co-authored-by: factory-droid[bot] <138933559+factory-droid[bot]@users.noreply.github.com>
</commit_message>
<xml_diff>
--- a/docs/presentation/nanolang-developer-overview.pptx
+++ b/docs/presentation/nanolang-developer-overview.pptx
@@ -516,7 +516,7 @@
           <a:lstStyle/>
           <a:p>
             <a:r>
-              <a:t>Authority: docs/PERSONA.md, README.md, docs/RELEASE_4.0.md.</a:t>
+              <a:t>Authority: docs/PERSONA.md, README.md, docs/RELEASE_4.4.md.</a:t>
             </a:r>
           </a:p>
           <a:p>
@@ -901,17 +901,17 @@
           <a:lstStyle/>
           <a:p>
             <a:r>
-              <a:t>Authority: docs/RELEASE_4.0.md, docs/ROADMAP.md, the open issue list, and git log v3.5.0..v4.0.0.</a:t>
-            </a:r>
-          </a:p>
-          <a:p>
-            <a:r>
-              <a:t>For a reader arriving from 3.5, the one-line delta is that my bytecode used to be well-formed and is now verified.</a:t>
-            </a:r>
-          </a:p>
-          <a:p>
-            <a:r>
-              <a:t>Phase 12 is 78 of 78. The right column is scope or filed defect, not vagueness.</a:t>
+              <a:t>Authority: docs/RELEASE_4.4.md, docs/ROADMAP.md, docs/FORTH_2012.md, docs/NSI_FABRIC.md, docs/NANO_EMACS.md.</a:t>
+            </a:r>
+          </a:p>
+          <a:p>
+            <a:r>
+              <a:t>Catalogs and machine-draft guides exist. JSON/TOON stay English.</a:t>
+            </a:r>
+          </a:p>
+          <a:p>
+            <a:r>
+              <a:t>The live editor uses bin/nano_emacs_worker, not dlopen.</a:t>
             </a:r>
           </a:p>
         </p:txBody>
@@ -4756,7 +4756,7 @@
                 </a:solidFill>
                 <a:latin typeface="Arial"/>
               </a:rPr>
-              <a:t>NANOLANG 4.0</a:t>
+              <a:t>NANOLANG 4.4</a:t>
             </a:r>
           </a:p>
         </p:txBody>
@@ -4857,7 +4857,7 @@
                 </a:solidFill>
                 <a:latin typeface="Arial"/>
               </a:rPr>
-              <a:t>A developer's view of my syntax, compiler, NanoISA, NanoVM, and what my verifier proves.</a:t>
+              <a:t>A developer's view of my syntax, compiler, NanoISA, NanoVM, NSI, and what my verifier proves.</a:t>
             </a:r>
           </a:p>
         </p:txBody>
@@ -4891,7 +4891,7 @@
                 </a:solidFill>
                 <a:latin typeface="Arial"/>
               </a:rPr>
-              <a:t>NanoISA v2 · NanoVM v2 · bytecode that is verified, not merely well-formed</a:t>
+              <a:t>Verified bytecode · Forth evidence · NSI fabric · isolated editor walker</a:t>
             </a:r>
           </a:p>
         </p:txBody>
@@ -7315,7 +7315,7 @@
                 </a:solidFill>
                 <a:latin typeface="Arial"/>
               </a:rPr>
-              <a:t>4.0 shipped. Here is what I have not done.</a:t>
+              <a:t>4.4 shipped. Here is what I have not done.</a:t>
             </a:r>
           </a:p>
         </p:txBody>
@@ -7349,7 +7349,7 @@
                 </a:solidFill>
                 <a:latin typeface="Arial"/>
               </a:rPr>
-              <a:t>107 commits since 3.5, and more new test code than new source. A known defect is not an unknown one.</a:t>
+              <a:t>One tag from v4.0.0. Product phases 4.1–4.4, not four Git tags.</a:t>
             </a:r>
           </a:p>
         </p:txBody>
@@ -7495,7 +7495,7 @@
                 </a:solidFill>
                 <a:latin typeface="Arial"/>
               </a:rPr>
-              <a:t>4.0 SHIPPED</a:t>
+              <a:t>4.4 SHIPPED</a:t>
             </a:r>
           </a:p>
         </p:txBody>
@@ -7529,7 +7529,7 @@
                 </a:solidFill>
                 <a:latin typeface="Arial"/>
               </a:rPr>
-              <a:t>v2 module format</a:t>
+              <a:t>verified NanoISA v2 (4.0)</a:t>
             </a:r>
           </a:p>
           <a:p>
@@ -7540,7 +7540,7 @@
                 </a:solidFill>
                 <a:latin typeface="Arial"/>
               </a:rPr>
-              <a:t>stack and type verification</a:t>
+              <a:t>Forth Core evidence</a:t>
             </a:r>
           </a:p>
           <a:p>
@@ -7551,7 +7551,7 @@
                 </a:solidFill>
                 <a:latin typeface="Arial"/>
               </a:rPr>
-              <a:t>return, depth, ownership</a:t>
+              <a:t>NSI v0 + POSIX fabric</a:t>
             </a:r>
           </a:p>
           <a:p>
@@ -7562,7 +7562,7 @@
                 </a:solidFill>
                 <a:latin typeface="Arial"/>
               </a:rPr>
-              <a:t>fuzzed parsing surfaces</a:t>
+              <a:t>unforgeable capabilities</a:t>
             </a:r>
           </a:p>
           <a:p>
@@ -7573,7 +7573,7 @@
                 </a:solidFill>
                 <a:latin typeface="Arial"/>
               </a:rPr>
-              <a:t>cycle collection</a:t>
+              <a:t>isolated editor walker</a:t>
             </a:r>
           </a:p>
           <a:p>
@@ -7584,7 +7584,7 @@
                 </a:solidFill>
                 <a:latin typeface="Arial"/>
               </a:rPr>
-              <a:t>honest measurement</a:t>
+              <a:t>six-language catalogs</a:t>
             </a:r>
           </a:p>
         </p:txBody>
@@ -7695,7 +7695,7 @@
                 </a:solidFill>
                 <a:latin typeface="Arial"/>
               </a:rPr>
-              <a:t>header dependencies (#211)</a:t>
+              <a:t>Standard System / INCLUDED</a:t>
             </a:r>
           </a:p>
           <a:p>
@@ -7706,7 +7706,7 @@
                 </a:solidFill>
                 <a:latin typeface="Arial"/>
               </a:rPr>
-              <a:t>module signing → 5.0</a:t>
+              <a:t>internationalized compiler</a:t>
             </a:r>
           </a:p>
           <a:p>
@@ -7717,7 +7717,7 @@
                 </a:solidFill>
                 <a:latin typeface="Arial"/>
               </a:rPr>
-              <a:t>LLVM and Wasm as</a:t>
+              <a:t>GNU Emacs / a kernel</a:t>
             </a:r>
           </a:p>
           <a:p>
@@ -7728,7 +7728,7 @@
                 </a:solidFill>
                 <a:latin typeface="Arial"/>
               </a:rPr>
-              <a:t>  NanoISA translators</a:t>
+              <a:t>CUDA or CPython wrap</a:t>
             </a:r>
           </a:p>
           <a:p>
@@ -7739,7 +7739,18 @@
                 </a:solidFill>
                 <a:latin typeface="Arial"/>
               </a:rPr>
-              <a:t>Forth 2012 → 4.1</a:t>
+              <a:t>header deps (#211)</a:t>
+            </a:r>
+          </a:p>
+          <a:p>
+            <a:r>
+              <a:rPr sz="1800" b="1">
+                <a:solidFill>
+                  <a:srgbClr val="EEF1F3"/>
+                </a:solidFill>
+                <a:latin typeface="Arial"/>
+              </a:rPr>
+              <a:t>5.0 One IR</a:t>
             </a:r>
           </a:p>
         </p:txBody>
@@ -7937,7 +7948,7 @@
                 </a:solidFill>
                 <a:latin typeface="Courier New"/>
               </a:rPr>
-              <a:t>docs/RELEASE_4.0.md · docs/ROADMAP.md · docs/NANOISA_MEASUREMENTS.md</a:t>
+              <a:t>docs/RELEASE_4.4.md · docs/ROADMAP.md · docs/NSI_FABRIC.md</a:t>
             </a:r>
           </a:p>
         </p:txBody>

</xml_diff>

<commit_message>
feat: 4.1–4.4 Forth evidence, catalogs, NSI, and POSIX fabric
Product 4.1–4.4 on feat/forth-core-suite. Last tagged GitHub release is v4.0.0.
Tag one v4.4.0 after this lands. I do not claim a Forth 2012 Standard System,
GNU Emacs, a kernel, a CUDA/CPython wrap, or completed i18n.

- 4.1: Jackson Core suite vendor pin and INCLUDE gap
- 4.2: catalogs and machine-draft guide editions
- 4.3: NSI v0 typed payloads
- 4.4: capabilities/POSIX fabric and isolated nano_emacs_worker
- CI: PIC/nanoc, GCC 15 truncation, gcov skip of Jackson word-set REFILL/PTY/IDE
</commit_message>
<xml_diff>
--- a/docs/presentation/nanolang-developer-overview.pptx
+++ b/docs/presentation/nanolang-developer-overview.pptx
@@ -516,7 +516,7 @@
           <a:lstStyle/>
           <a:p>
             <a:r>
-              <a:t>Authority: docs/PERSONA.md, README.md, docs/RELEASE_4.0.md.</a:t>
+              <a:t>Authority: docs/PERSONA.md, README.md, docs/RELEASE_4.4.md.</a:t>
             </a:r>
           </a:p>
           <a:p>
@@ -901,17 +901,17 @@
           <a:lstStyle/>
           <a:p>
             <a:r>
-              <a:t>Authority: docs/RELEASE_4.0.md, docs/ROADMAP.md, the open issue list, and git log v3.5.0..v4.0.0.</a:t>
-            </a:r>
-          </a:p>
-          <a:p>
-            <a:r>
-              <a:t>For a reader arriving from 3.5, the one-line delta is that my bytecode used to be well-formed and is now verified.</a:t>
-            </a:r>
-          </a:p>
-          <a:p>
-            <a:r>
-              <a:t>Phase 12 is 78 of 78. The right column is scope or filed defect, not vagueness.</a:t>
+              <a:t>Authority: docs/RELEASE_4.4.md, docs/ROADMAP.md, docs/FORTH_2012.md, docs/NSI_FABRIC.md, docs/NANO_EMACS.md.</a:t>
+            </a:r>
+          </a:p>
+          <a:p>
+            <a:r>
+              <a:t>Catalogs and machine-draft guides exist. JSON/TOON stay English.</a:t>
+            </a:r>
+          </a:p>
+          <a:p>
+            <a:r>
+              <a:t>The live editor uses bin/nano_emacs_worker, not dlopen.</a:t>
             </a:r>
           </a:p>
         </p:txBody>
@@ -4756,7 +4756,7 @@
                 </a:solidFill>
                 <a:latin typeface="Arial"/>
               </a:rPr>
-              <a:t>NANOLANG 4.0</a:t>
+              <a:t>NANOLANG 4.4</a:t>
             </a:r>
           </a:p>
         </p:txBody>
@@ -4857,7 +4857,7 @@
                 </a:solidFill>
                 <a:latin typeface="Arial"/>
               </a:rPr>
-              <a:t>A developer's view of my syntax, compiler, NanoISA, NanoVM, and what my verifier proves.</a:t>
+              <a:t>A developer's view of my syntax, compiler, NanoISA, NanoVM, NSI, and what my verifier proves.</a:t>
             </a:r>
           </a:p>
         </p:txBody>
@@ -4891,7 +4891,7 @@
                 </a:solidFill>
                 <a:latin typeface="Arial"/>
               </a:rPr>
-              <a:t>NanoISA v2 · NanoVM v2 · bytecode that is verified, not merely well-formed</a:t>
+              <a:t>Verified bytecode · Forth evidence · NSI fabric · isolated editor walker</a:t>
             </a:r>
           </a:p>
         </p:txBody>
@@ -7315,7 +7315,7 @@
                 </a:solidFill>
                 <a:latin typeface="Arial"/>
               </a:rPr>
-              <a:t>4.0 shipped. Here is what I have not done.</a:t>
+              <a:t>4.4 shipped. Here is what I have not done.</a:t>
             </a:r>
           </a:p>
         </p:txBody>
@@ -7349,7 +7349,7 @@
                 </a:solidFill>
                 <a:latin typeface="Arial"/>
               </a:rPr>
-              <a:t>107 commits since 3.5, and more new test code than new source. A known defect is not an unknown one.</a:t>
+              <a:t>One tag from v4.0.0. Product phases 4.1–4.4, not four Git tags.</a:t>
             </a:r>
           </a:p>
         </p:txBody>
@@ -7495,7 +7495,7 @@
                 </a:solidFill>
                 <a:latin typeface="Arial"/>
               </a:rPr>
-              <a:t>4.0 SHIPPED</a:t>
+              <a:t>4.4 SHIPPED</a:t>
             </a:r>
           </a:p>
         </p:txBody>
@@ -7529,7 +7529,7 @@
                 </a:solidFill>
                 <a:latin typeface="Arial"/>
               </a:rPr>
-              <a:t>v2 module format</a:t>
+              <a:t>verified NanoISA v2 (4.0)</a:t>
             </a:r>
           </a:p>
           <a:p>
@@ -7540,7 +7540,7 @@
                 </a:solidFill>
                 <a:latin typeface="Arial"/>
               </a:rPr>
-              <a:t>stack and type verification</a:t>
+              <a:t>Forth Core evidence</a:t>
             </a:r>
           </a:p>
           <a:p>
@@ -7551,7 +7551,7 @@
                 </a:solidFill>
                 <a:latin typeface="Arial"/>
               </a:rPr>
-              <a:t>return, depth, ownership</a:t>
+              <a:t>NSI v0 + POSIX fabric</a:t>
             </a:r>
           </a:p>
           <a:p>
@@ -7562,7 +7562,7 @@
                 </a:solidFill>
                 <a:latin typeface="Arial"/>
               </a:rPr>
-              <a:t>fuzzed parsing surfaces</a:t>
+              <a:t>unforgeable capabilities</a:t>
             </a:r>
           </a:p>
           <a:p>
@@ -7573,7 +7573,7 @@
                 </a:solidFill>
                 <a:latin typeface="Arial"/>
               </a:rPr>
-              <a:t>cycle collection</a:t>
+              <a:t>isolated editor walker</a:t>
             </a:r>
           </a:p>
           <a:p>
@@ -7584,7 +7584,7 @@
                 </a:solidFill>
                 <a:latin typeface="Arial"/>
               </a:rPr>
-              <a:t>honest measurement</a:t>
+              <a:t>six-language catalogs</a:t>
             </a:r>
           </a:p>
         </p:txBody>
@@ -7695,7 +7695,7 @@
                 </a:solidFill>
                 <a:latin typeface="Arial"/>
               </a:rPr>
-              <a:t>header dependencies (#211)</a:t>
+              <a:t>Standard System / INCLUDED</a:t>
             </a:r>
           </a:p>
           <a:p>
@@ -7706,7 +7706,7 @@
                 </a:solidFill>
                 <a:latin typeface="Arial"/>
               </a:rPr>
-              <a:t>module signing → 5.0</a:t>
+              <a:t>internationalized compiler</a:t>
             </a:r>
           </a:p>
           <a:p>
@@ -7717,7 +7717,7 @@
                 </a:solidFill>
                 <a:latin typeface="Arial"/>
               </a:rPr>
-              <a:t>LLVM and Wasm as</a:t>
+              <a:t>GNU Emacs / a kernel</a:t>
             </a:r>
           </a:p>
           <a:p>
@@ -7728,7 +7728,7 @@
                 </a:solidFill>
                 <a:latin typeface="Arial"/>
               </a:rPr>
-              <a:t>  NanoISA translators</a:t>
+              <a:t>CUDA or CPython wrap</a:t>
             </a:r>
           </a:p>
           <a:p>
@@ -7739,7 +7739,18 @@
                 </a:solidFill>
                 <a:latin typeface="Arial"/>
               </a:rPr>
-              <a:t>Forth 2012 → 4.1</a:t>
+              <a:t>header deps (#211)</a:t>
+            </a:r>
+          </a:p>
+          <a:p>
+            <a:r>
+              <a:rPr sz="1800" b="1">
+                <a:solidFill>
+                  <a:srgbClr val="EEF1F3"/>
+                </a:solidFill>
+                <a:latin typeface="Arial"/>
+              </a:rPr>
+              <a:t>5.0 One IR</a:t>
             </a:r>
           </a:p>
         </p:txBody>
@@ -7937,7 +7948,7 @@
                 </a:solidFill>
                 <a:latin typeface="Courier New"/>
               </a:rPr>
-              <a:t>docs/RELEASE_4.0.md · docs/ROADMAP.md · docs/NANOISA_MEASUREMENTS.md</a:t>
+              <a:t>docs/RELEASE_4.4.md · docs/ROADMAP.md · docs/NSI_FABRIC.md</a:t>
             </a:r>
           </a:p>
         </p:txBody>

</xml_diff>

<commit_message>
docs: frame 4.1-4.5 as a language and secure runtime
The last public GitHub Release is v4.0.0. Public notes, LinkedIn draft,
developer deck, and user guide now describe v4.5.0 covering 4.1-4.5,
including NSI, capabilities, POSIX fabric, and the trap journal.

Related to task_d2f80f3c3ca6ee5f81070545a5a2ac5f.
</commit_message>
<xml_diff>
--- a/docs/presentation/nanolang-developer-overview.pptx
+++ b/docs/presentation/nanolang-developer-overview.pptx
@@ -20,6 +20,7 @@
     <p:sldId id="268" r:id="rId20"/>
     <p:sldId id="269" r:id="rId21"/>
     <p:sldId id="270" r:id="rId22"/>
+    <p:sldId id="271" r:id="rId23"/>
   </p:sldIdLst>
   <p:sldSz cx="12191695" cy="6858000" type="screen4x3"/>
   <p:notesSz cx="6858000" cy="9144000"/>
@@ -516,7 +517,12 @@
           <a:lstStyle/>
           <a:p>
             <a:r>
-              <a:t>Authority: docs/PERSONA.md, README.md, docs/RELEASE_4.4.md.</a:t>
+              <a:t>Authority: docs/PERSONA.md, README.md, docs/RELEASE_4.5.md.</a:t>
+            </a:r>
+          </a:p>
+          <a:p>
+            <a:r>
+              <a:t>I am a language and a secure runtime. I do not claim a kernel.</a:t>
             </a:r>
           </a:p>
           <a:p>
@@ -901,17 +907,17 @@
           <a:lstStyle/>
           <a:p>
             <a:r>
-              <a:t>Authority: docs/RELEASE_4.4.md, docs/ROADMAP.md, docs/FORTH_2012.md, docs/NSI_FABRIC.md, docs/NANO_EMACS.md.</a:t>
-            </a:r>
-          </a:p>
-          <a:p>
-            <a:r>
-              <a:t>Catalogs and machine-draft guides exist. JSON/TOON stay English.</a:t>
-            </a:r>
-          </a:p>
-          <a:p>
-            <a:r>
-              <a:t>The live editor uses bin/nano_emacs_worker, not dlopen.</a:t>
+              <a:t>Authority: docs/NSI.md, docs/NSI_FABRIC.md, docs/NSI_EFFECTS.md, schema/nsi/effect_map.v0.json.</a:t>
+            </a:r>
+          </a:p>
+          <a:p>
+            <a:r>
+              <a:t>State has no host cap. Err maps to TRAP_ERROR and invents no NSI method.</a:t>
+            </a:r>
+          </a:p>
+          <a:p>
+            <a:r>
+              <a:t>I do not claim a kernel, AES, PKI, or that the journal is wired into every trap.</a:t>
             </a:r>
           </a:p>
         </p:txBody>
@@ -981,7 +987,87 @@
           <a:lstStyle/>
           <a:p>
             <a:r>
-              <a:t>Authority: CONTRIBUTING.md, docs/PERSONA.md, docs/ROADMAP.md.</a:t>
+              <a:t>Authority: docs/RELEASE_4.5.md, docs/ROADMAP.md, docs/FORTH_STANDARD_SYSTEM.md, docs/NSI_EFFECTS.md.</a:t>
+            </a:r>
+          </a:p>
+          <a:p>
+            <a:r>
+              <a:t>Catalogs and machine-draft guides exist. JSON/TOON stay English.</a:t>
+            </a:r>
+          </a:p>
+          <a:p>
+            <a:r>
+              <a:t>The live editor uses bin/nano_emacs_worker, not dlopen.</a:t>
+            </a:r>
+          </a:p>
+        </p:txBody>
+      </p:sp>
+      <p:sp>
+        <p:nvSpPr>
+          <p:cNvPr id="4" name="Slide Number Placeholder 3"/>
+          <p:cNvSpPr>
+            <a:spLocks noGrp="1"/>
+          </p:cNvSpPr>
+          <p:nvPr>
+            <p:ph type="sldNum" idx="5" sz="quarter"/>
+          </p:nvPr>
+        </p:nvSpPr>
+        <p:spPr/>
+      </p:sp>
+    </p:spTree>
+  </p:cSld>
+  <p:clrMapOvr>
+    <a:masterClrMapping/>
+  </p:clrMapOvr>
+</p:notes>
+</file>
+
+<file path=ppt/notesSlides/notesSlide16.xml><?xml version="1.0" encoding="utf-8"?>
+<p:notes xmlns:a="http://schemas.openxmlformats.org/drawingml/2006/main" xmlns:p="http://schemas.openxmlformats.org/presentationml/2006/main" xmlns:r="http://schemas.openxmlformats.org/officeDocument/2006/relationships">
+  <p:cSld>
+    <p:spTree>
+      <p:nvGrpSpPr>
+        <p:cNvPr id="1" name=""/>
+        <p:cNvGrpSpPr/>
+        <p:nvPr/>
+      </p:nvGrpSpPr>
+      <p:grpSpPr>
+        <a:xfrm>
+          <a:off x="0" y="0"/>
+          <a:ext cx="0" cy="0"/>
+          <a:chOff x="0" y="0"/>
+          <a:chExt cx="0" cy="0"/>
+        </a:xfrm>
+      </p:grpSpPr>
+      <p:sp>
+        <p:nvSpPr>
+          <p:cNvPr id="2" name="Slide Image Placeholder 1"/>
+          <p:cNvSpPr>
+            <a:spLocks noGrp="1"/>
+          </p:cNvSpPr>
+          <p:nvPr>
+            <p:ph type="sldImg" idx="2"/>
+          </p:nvPr>
+        </p:nvSpPr>
+        <p:spPr/>
+      </p:sp>
+      <p:sp>
+        <p:nvSpPr>
+          <p:cNvPr id="3" name="Notes Placeholder 2"/>
+          <p:cNvSpPr>
+            <a:spLocks noGrp="1"/>
+          </p:cNvSpPr>
+          <p:nvPr>
+            <p:ph type="body" idx="3" sz="quarter"/>
+          </p:nvPr>
+        </p:nvSpPr>
+        <p:spPr/>
+        <p:txBody>
+          <a:bodyPr/>
+          <a:lstStyle/>
+          <a:p>
+            <a:r>
+              <a:t>Authority: CONTRIBUTING.md, docs/PERSONA.md, docs/ROADMAP.md, docs/RELEASE_4.5.md.</a:t>
             </a:r>
           </a:p>
         </p:txBody>
@@ -4756,7 +4842,7 @@
                 </a:solidFill>
                 <a:latin typeface="Arial"/>
               </a:rPr>
-              <a:t>NANOLANG 4.4</a:t>
+              <a:t>NANOLANG 4.5</a:t>
             </a:r>
           </a:p>
         </p:txBody>
@@ -4857,7 +4943,7 @@
                 </a:solidFill>
                 <a:latin typeface="Arial"/>
               </a:rPr>
-              <a:t>A developer's view of my syntax, compiler, NanoISA, NanoVM, NSI, and what my verifier proves.</a:t>
+              <a:t>A developer's view of my syntax, compiler, NanoISA, and the secure runtime I host on POSIX.</a:t>
             </a:r>
           </a:p>
         </p:txBody>
@@ -4891,7 +4977,7 @@
                 </a:solidFill>
                 <a:latin typeface="Arial"/>
               </a:rPr>
-              <a:t>Verified bytecode · Forth evidence · NSI fabric · isolated editor walker</a:t>
+              <a:t>Verified bytecode · NSI · capabilities · fabric · trap journal</a:t>
             </a:r>
           </a:p>
         </p:txBody>
@@ -7258,7 +7344,7 @@
             <a:avLst/>
           </a:prstGeom>
           <a:solidFill>
-            <a:srgbClr val="101317"/>
+            <a:srgbClr val="EEF1F3"/>
           </a:solidFill>
           <a:ln>
             <a:noFill/>
@@ -7311,11 +7397,11 @@
             <a:r>
               <a:rPr sz="2800" b="1">
                 <a:solidFill>
-                  <a:srgbClr val="EEF1F3"/>
-                </a:solidFill>
-                <a:latin typeface="Arial"/>
-              </a:rPr>
-              <a:t>4.4 shipped. Here is what I have not done.</a:t>
+                  <a:srgbClr val="101317"/>
+                </a:solidFill>
+                <a:latin typeface="Arial"/>
+              </a:rPr>
+              <a:t>I host a secure runtime on an ordinary kernel.</a:t>
             </a:r>
           </a:p>
         </p:txBody>
@@ -7345,11 +7431,11 @@
             <a:r>
               <a:rPr sz="1300" b="0">
                 <a:solidFill>
-                  <a:srgbClr val="72B7D6"/>
-                </a:solidFill>
-                <a:latin typeface="Arial"/>
-              </a:rPr>
-              <a:t>One tag from v4.0.0. Product phases 4.1–4.4, not four Git tags.</a:t>
+                  <a:srgbClr val="65707C"/>
+                </a:solidFill>
+                <a:latin typeface="Arial"/>
+              </a:rPr>
+              <a:t>Contracts, capabilities, a POSIX fabric, and a journal. Five layers. Not synonyms.</a:t>
             </a:r>
           </a:p>
         </p:txBody>
@@ -7431,8 +7517,8 @@
         </p:nvSpPr>
         <p:spPr>
           <a:xfrm>
-            <a:off x="731520" y="1828800"/>
-            <a:ext cx="5166360" cy="3566160"/>
+            <a:off x="502920" y="1965960"/>
+            <a:ext cx="2103120" cy="1554480"/>
           </a:xfrm>
           <a:prstGeom prst="roundRect">
             <a:avLst/>
@@ -7474,28 +7560,28 @@
         </p:nvSpPr>
         <p:spPr>
           <a:xfrm>
-            <a:off x="1005840" y="2148840"/>
-            <a:ext cx="4480560" cy="274320"/>
-          </a:xfrm>
-          <a:prstGeom prst="rect">
-            <a:avLst/>
-          </a:prstGeom>
-          <a:noFill/>
-        </p:spPr>
-        <p:txBody>
-          <a:bodyPr wrap="square" lIns="45720" rIns="45720" tIns="27432" bIns="27432" anchor="t">
-            <a:spAutoFit/>
-          </a:bodyPr>
-          <a:lstStyle/>
-          <a:p>
-            <a:r>
-              <a:rPr sz="1500" b="1">
+            <a:off x="612648" y="2194560"/>
+            <a:ext cx="1874519" cy="320040"/>
+          </a:xfrm>
+          <a:prstGeom prst="rect">
+            <a:avLst/>
+          </a:prstGeom>
+          <a:noFill/>
+        </p:spPr>
+        <p:txBody>
+          <a:bodyPr wrap="square" lIns="45720" rIns="45720" tIns="27432" bIns="27432" anchor="t">
+            <a:spAutoFit/>
+          </a:bodyPr>
+          <a:lstStyle/>
+          <a:p>
+            <a:r>
+              <a:rPr sz="1400" b="1">
                 <a:solidFill>
                   <a:srgbClr val="76B900"/>
                 </a:solidFill>
-                <a:latin typeface="Arial"/>
-              </a:rPr>
-              <a:t>4.4 SHIPPED</a:t>
+                <a:latin typeface="Courier New"/>
+              </a:rPr>
+              <a:t>EFFECT</a:t>
             </a:r>
           </a:p>
         </p:txBody>
@@ -7508,83 +7594,28 @@
         </p:nvSpPr>
         <p:spPr>
           <a:xfrm>
-            <a:off x="1005840" y="2651760"/>
-            <a:ext cx="4297680" cy="2377440"/>
-          </a:xfrm>
-          <a:prstGeom prst="rect">
-            <a:avLst/>
-          </a:prstGeom>
-          <a:noFill/>
-        </p:spPr>
-        <p:txBody>
-          <a:bodyPr wrap="square" lIns="45720" rIns="45720" tIns="27432" bIns="27432" anchor="t">
-            <a:spAutoFit/>
-          </a:bodyPr>
-          <a:lstStyle/>
-          <a:p>
-            <a:r>
-              <a:rPr sz="1800" b="1">
+            <a:off x="612648" y="2651760"/>
+            <a:ext cx="1874519" cy="502920"/>
+          </a:xfrm>
+          <a:prstGeom prst="rect">
+            <a:avLst/>
+          </a:prstGeom>
+          <a:noFill/>
+        </p:spPr>
+        <p:txBody>
+          <a:bodyPr wrap="square" lIns="45720" rIns="45720" tIns="27432" bIns="27432" anchor="t">
+            <a:spAutoFit/>
+          </a:bodyPr>
+          <a:lstStyle/>
+          <a:p>
+            <a:r>
+              <a:rPr sz="1400" b="0">
                 <a:solidFill>
                   <a:srgbClr val="EEF1F3"/>
                 </a:solidFill>
                 <a:latin typeface="Arial"/>
               </a:rPr>
-              <a:t>verified NanoISA v2 (4.0)</a:t>
-            </a:r>
-          </a:p>
-          <a:p>
-            <a:r>
-              <a:rPr sz="1800" b="1">
-                <a:solidFill>
-                  <a:srgbClr val="EEF1F3"/>
-                </a:solidFill>
-                <a:latin typeface="Arial"/>
-              </a:rPr>
-              <a:t>Forth Core evidence</a:t>
-            </a:r>
-          </a:p>
-          <a:p>
-            <a:r>
-              <a:rPr sz="1800" b="1">
-                <a:solidFill>
-                  <a:srgbClr val="EEF1F3"/>
-                </a:solidFill>
-                <a:latin typeface="Arial"/>
-              </a:rPr>
-              <a:t>NSI v0 + POSIX fabric</a:t>
-            </a:r>
-          </a:p>
-          <a:p>
-            <a:r>
-              <a:rPr sz="1800" b="1">
-                <a:solidFill>
-                  <a:srgbClr val="EEF1F3"/>
-                </a:solidFill>
-                <a:latin typeface="Arial"/>
-              </a:rPr>
-              <a:t>unforgeable capabilities</a:t>
-            </a:r>
-          </a:p>
-          <a:p>
-            <a:r>
-              <a:rPr sz="1800" b="1">
-                <a:solidFill>
-                  <a:srgbClr val="EEF1F3"/>
-                </a:solidFill>
-                <a:latin typeface="Arial"/>
-              </a:rPr>
-              <a:t>isolated editor walker</a:t>
-            </a:r>
-          </a:p>
-          <a:p>
-            <a:r>
-              <a:rPr sz="1800" b="1">
-                <a:solidFill>
-                  <a:srgbClr val="EEF1F3"/>
-                </a:solidFill>
-                <a:latin typeface="Arial"/>
-              </a:rPr>
-              <a:t>six-language catalogs</a:t>
+              <a:t>source row</a:t>
             </a:r>
           </a:p>
         </p:txBody>
@@ -7597,8 +7628,452 @@
         </p:nvSpPr>
         <p:spPr>
           <a:xfrm>
-            <a:off x="6309360" y="1828800"/>
-            <a:ext cx="5166360" cy="3566160"/>
+            <a:off x="2788920" y="1965960"/>
+            <a:ext cx="2103120" cy="1554480"/>
+          </a:xfrm>
+          <a:prstGeom prst="roundRect">
+            <a:avLst/>
+          </a:prstGeom>
+          <a:solidFill>
+            <a:srgbClr val="23282F"/>
+          </a:solidFill>
+          <a:ln>
+            <a:noFill/>
+          </a:ln>
+        </p:spPr>
+        <p:style>
+          <a:lnRef idx="1">
+            <a:schemeClr val="accent1"/>
+          </a:lnRef>
+          <a:fillRef idx="3">
+            <a:schemeClr val="accent1"/>
+          </a:fillRef>
+          <a:effectRef idx="2">
+            <a:schemeClr val="accent1"/>
+          </a:effectRef>
+          <a:fontRef idx="minor">
+            <a:schemeClr val="lt1"/>
+          </a:fontRef>
+        </p:style>
+        <p:txBody>
+          <a:bodyPr rtlCol="0" anchor="ctr"/>
+          <a:lstStyle/>
+          <a:p>
+            <a:pPr algn="ctr"/>
+          </a:p>
+        </p:txBody>
+      </p:sp>
+      <p:sp>
+        <p:nvSpPr>
+          <p:cNvPr id="11" name="TextBox 10"/>
+          <p:cNvSpPr txBox="1"/>
+          <p:nvPr/>
+        </p:nvSpPr>
+        <p:spPr>
+          <a:xfrm>
+            <a:off x="2898648" y="2194560"/>
+            <a:ext cx="1874519" cy="320040"/>
+          </a:xfrm>
+          <a:prstGeom prst="rect">
+            <a:avLst/>
+          </a:prstGeom>
+          <a:noFill/>
+        </p:spPr>
+        <p:txBody>
+          <a:bodyPr wrap="square" lIns="45720" rIns="45720" tIns="27432" bIns="27432" anchor="t">
+            <a:spAutoFit/>
+          </a:bodyPr>
+          <a:lstStyle/>
+          <a:p>
+            <a:r>
+              <a:rPr sz="1400" b="1">
+                <a:solidFill>
+                  <a:srgbClr val="76B900"/>
+                </a:solidFill>
+                <a:latin typeface="Courier New"/>
+              </a:rPr>
+              <a:t>MANIFEST</a:t>
+            </a:r>
+          </a:p>
+        </p:txBody>
+      </p:sp>
+      <p:sp>
+        <p:nvSpPr>
+          <p:cNvPr id="12" name="TextBox 11"/>
+          <p:cNvSpPr txBox="1"/>
+          <p:nvPr/>
+        </p:nvSpPr>
+        <p:spPr>
+          <a:xfrm>
+            <a:off x="2898648" y="2651760"/>
+            <a:ext cx="1874519" cy="502920"/>
+          </a:xfrm>
+          <a:prstGeom prst="rect">
+            <a:avLst/>
+          </a:prstGeom>
+          <a:noFill/>
+        </p:spPr>
+        <p:txBody>
+          <a:bodyPr wrap="square" lIns="45720" rIns="45720" tIns="27432" bIns="27432" anchor="t">
+            <a:spAutoFit/>
+          </a:bodyPr>
+          <a:lstStyle/>
+          <a:p>
+            <a:r>
+              <a:rPr sz="1400" b="0">
+                <a:solidFill>
+                  <a:srgbClr val="EEF1F3"/>
+                </a:solidFill>
+                <a:latin typeface="Arial"/>
+              </a:rPr>
+              <a:t>required caps</a:t>
+            </a:r>
+          </a:p>
+        </p:txBody>
+      </p:sp>
+      <p:sp>
+        <p:nvSpPr>
+          <p:cNvPr id="13" name="Rounded Rectangle 12"/>
+          <p:cNvSpPr/>
+          <p:nvPr/>
+        </p:nvSpPr>
+        <p:spPr>
+          <a:xfrm>
+            <a:off x="5074920" y="1965960"/>
+            <a:ext cx="2103120" cy="1554480"/>
+          </a:xfrm>
+          <a:prstGeom prst="roundRect">
+            <a:avLst/>
+          </a:prstGeom>
+          <a:solidFill>
+            <a:srgbClr val="23282F"/>
+          </a:solidFill>
+          <a:ln>
+            <a:noFill/>
+          </a:ln>
+        </p:spPr>
+        <p:style>
+          <a:lnRef idx="1">
+            <a:schemeClr val="accent1"/>
+          </a:lnRef>
+          <a:fillRef idx="3">
+            <a:schemeClr val="accent1"/>
+          </a:fillRef>
+          <a:effectRef idx="2">
+            <a:schemeClr val="accent1"/>
+          </a:effectRef>
+          <a:fontRef idx="minor">
+            <a:schemeClr val="lt1"/>
+          </a:fontRef>
+        </p:style>
+        <p:txBody>
+          <a:bodyPr rtlCol="0" anchor="ctr"/>
+          <a:lstStyle/>
+          <a:p>
+            <a:pPr algn="ctr"/>
+          </a:p>
+        </p:txBody>
+      </p:sp>
+      <p:sp>
+        <p:nvSpPr>
+          <p:cNvPr id="14" name="TextBox 13"/>
+          <p:cNvSpPr txBox="1"/>
+          <p:nvPr/>
+        </p:nvSpPr>
+        <p:spPr>
+          <a:xfrm>
+            <a:off x="5184648" y="2194560"/>
+            <a:ext cx="1874519" cy="320040"/>
+          </a:xfrm>
+          <a:prstGeom prst="rect">
+            <a:avLst/>
+          </a:prstGeom>
+          <a:noFill/>
+        </p:spPr>
+        <p:txBody>
+          <a:bodyPr wrap="square" lIns="45720" rIns="45720" tIns="27432" bIns="27432" anchor="t">
+            <a:spAutoFit/>
+          </a:bodyPr>
+          <a:lstStyle/>
+          <a:p>
+            <a:r>
+              <a:rPr sz="1400" b="1">
+                <a:solidFill>
+                  <a:srgbClr val="76B900"/>
+                </a:solidFill>
+                <a:latin typeface="Courier New"/>
+              </a:rPr>
+              <a:t>TRAP</a:t>
+            </a:r>
+          </a:p>
+        </p:txBody>
+      </p:sp>
+      <p:sp>
+        <p:nvSpPr>
+          <p:cNvPr id="15" name="TextBox 14"/>
+          <p:cNvSpPr txBox="1"/>
+          <p:nvPr/>
+        </p:nvSpPr>
+        <p:spPr>
+          <a:xfrm>
+            <a:off x="5184648" y="2651760"/>
+            <a:ext cx="1874519" cy="502920"/>
+          </a:xfrm>
+          <a:prstGeom prst="rect">
+            <a:avLst/>
+          </a:prstGeom>
+          <a:noFill/>
+        </p:spPr>
+        <p:txBody>
+          <a:bodyPr wrap="square" lIns="45720" rIns="45720" tIns="27432" bIns="27432" anchor="t">
+            <a:spAutoFit/>
+          </a:bodyPr>
+          <a:lstStyle/>
+          <a:p>
+            <a:r>
+              <a:rPr sz="1400" b="0">
+                <a:solidFill>
+                  <a:srgbClr val="EEF1F3"/>
+                </a:solidFill>
+                <a:latin typeface="Arial"/>
+              </a:rPr>
+              <a:t>NanoISA</a:t>
+            </a:r>
+          </a:p>
+        </p:txBody>
+      </p:sp>
+      <p:sp>
+        <p:nvSpPr>
+          <p:cNvPr id="16" name="Rounded Rectangle 15"/>
+          <p:cNvSpPr/>
+          <p:nvPr/>
+        </p:nvSpPr>
+        <p:spPr>
+          <a:xfrm>
+            <a:off x="7360920" y="1965960"/>
+            <a:ext cx="2103120" cy="1554480"/>
+          </a:xfrm>
+          <a:prstGeom prst="roundRect">
+            <a:avLst/>
+          </a:prstGeom>
+          <a:solidFill>
+            <a:srgbClr val="23282F"/>
+          </a:solidFill>
+          <a:ln>
+            <a:noFill/>
+          </a:ln>
+        </p:spPr>
+        <p:style>
+          <a:lnRef idx="1">
+            <a:schemeClr val="accent1"/>
+          </a:lnRef>
+          <a:fillRef idx="3">
+            <a:schemeClr val="accent1"/>
+          </a:fillRef>
+          <a:effectRef idx="2">
+            <a:schemeClr val="accent1"/>
+          </a:effectRef>
+          <a:fontRef idx="minor">
+            <a:schemeClr val="lt1"/>
+          </a:fontRef>
+        </p:style>
+        <p:txBody>
+          <a:bodyPr rtlCol="0" anchor="ctr"/>
+          <a:lstStyle/>
+          <a:p>
+            <a:pPr algn="ctr"/>
+          </a:p>
+        </p:txBody>
+      </p:sp>
+      <p:sp>
+        <p:nvSpPr>
+          <p:cNvPr id="17" name="TextBox 16"/>
+          <p:cNvSpPr txBox="1"/>
+          <p:nvPr/>
+        </p:nvSpPr>
+        <p:spPr>
+          <a:xfrm>
+            <a:off x="7470648" y="2194560"/>
+            <a:ext cx="1874519" cy="320040"/>
+          </a:xfrm>
+          <a:prstGeom prst="rect">
+            <a:avLst/>
+          </a:prstGeom>
+          <a:noFill/>
+        </p:spPr>
+        <p:txBody>
+          <a:bodyPr wrap="square" lIns="45720" rIns="45720" tIns="27432" bIns="27432" anchor="t">
+            <a:spAutoFit/>
+          </a:bodyPr>
+          <a:lstStyle/>
+          <a:p>
+            <a:r>
+              <a:rPr sz="1400" b="1">
+                <a:solidFill>
+                  <a:srgbClr val="76B900"/>
+                </a:solidFill>
+                <a:latin typeface="Courier New"/>
+              </a:rPr>
+              <a:t>NSI</a:t>
+            </a:r>
+          </a:p>
+        </p:txBody>
+      </p:sp>
+      <p:sp>
+        <p:nvSpPr>
+          <p:cNvPr id="18" name="TextBox 17"/>
+          <p:cNvSpPr txBox="1"/>
+          <p:nvPr/>
+        </p:nvSpPr>
+        <p:spPr>
+          <a:xfrm>
+            <a:off x="7470648" y="2651760"/>
+            <a:ext cx="1874519" cy="502920"/>
+          </a:xfrm>
+          <a:prstGeom prst="rect">
+            <a:avLst/>
+          </a:prstGeom>
+          <a:noFill/>
+        </p:spPr>
+        <p:txBody>
+          <a:bodyPr wrap="square" lIns="45720" rIns="45720" tIns="27432" bIns="27432" anchor="t">
+            <a:spAutoFit/>
+          </a:bodyPr>
+          <a:lstStyle/>
+          <a:p>
+            <a:r>
+              <a:rPr sz="1400" b="0">
+                <a:solidFill>
+                  <a:srgbClr val="EEF1F3"/>
+                </a:solidFill>
+                <a:latin typeface="Arial"/>
+              </a:rPr>
+              <a:t>method id</a:t>
+            </a:r>
+          </a:p>
+        </p:txBody>
+      </p:sp>
+      <p:sp>
+        <p:nvSpPr>
+          <p:cNvPr id="19" name="Rounded Rectangle 18"/>
+          <p:cNvSpPr/>
+          <p:nvPr/>
+        </p:nvSpPr>
+        <p:spPr>
+          <a:xfrm>
+            <a:off x="9646920" y="1965960"/>
+            <a:ext cx="2103120" cy="1554480"/>
+          </a:xfrm>
+          <a:prstGeom prst="roundRect">
+            <a:avLst/>
+          </a:prstGeom>
+          <a:solidFill>
+            <a:srgbClr val="23282F"/>
+          </a:solidFill>
+          <a:ln>
+            <a:noFill/>
+          </a:ln>
+        </p:spPr>
+        <p:style>
+          <a:lnRef idx="1">
+            <a:schemeClr val="accent1"/>
+          </a:lnRef>
+          <a:fillRef idx="3">
+            <a:schemeClr val="accent1"/>
+          </a:fillRef>
+          <a:effectRef idx="2">
+            <a:schemeClr val="accent1"/>
+          </a:effectRef>
+          <a:fontRef idx="minor">
+            <a:schemeClr val="lt1"/>
+          </a:fontRef>
+        </p:style>
+        <p:txBody>
+          <a:bodyPr rtlCol="0" anchor="ctr"/>
+          <a:lstStyle/>
+          <a:p>
+            <a:pPr algn="ctr"/>
+          </a:p>
+        </p:txBody>
+      </p:sp>
+      <p:sp>
+        <p:nvSpPr>
+          <p:cNvPr id="20" name="TextBox 19"/>
+          <p:cNvSpPr txBox="1"/>
+          <p:nvPr/>
+        </p:nvSpPr>
+        <p:spPr>
+          <a:xfrm>
+            <a:off x="9756648" y="2194560"/>
+            <a:ext cx="1874519" cy="320040"/>
+          </a:xfrm>
+          <a:prstGeom prst="rect">
+            <a:avLst/>
+          </a:prstGeom>
+          <a:noFill/>
+        </p:spPr>
+        <p:txBody>
+          <a:bodyPr wrap="square" lIns="45720" rIns="45720" tIns="27432" bIns="27432" anchor="t">
+            <a:spAutoFit/>
+          </a:bodyPr>
+          <a:lstStyle/>
+          <a:p>
+            <a:r>
+              <a:rPr sz="1400" b="1">
+                <a:solidFill>
+                  <a:srgbClr val="76B900"/>
+                </a:solidFill>
+                <a:latin typeface="Courier New"/>
+              </a:rPr>
+              <a:t>CAP</a:t>
+            </a:r>
+          </a:p>
+        </p:txBody>
+      </p:sp>
+      <p:sp>
+        <p:nvSpPr>
+          <p:cNvPr id="21" name="TextBox 20"/>
+          <p:cNvSpPr txBox="1"/>
+          <p:nvPr/>
+        </p:nvSpPr>
+        <p:spPr>
+          <a:xfrm>
+            <a:off x="9756648" y="2651760"/>
+            <a:ext cx="1874519" cy="502920"/>
+          </a:xfrm>
+          <a:prstGeom prst="rect">
+            <a:avLst/>
+          </a:prstGeom>
+          <a:noFill/>
+        </p:spPr>
+        <p:txBody>
+          <a:bodyPr wrap="square" lIns="45720" rIns="45720" tIns="27432" bIns="27432" anchor="t">
+            <a:spAutoFit/>
+          </a:bodyPr>
+          <a:lstStyle/>
+          <a:p>
+            <a:r>
+              <a:rPr sz="1400" b="0">
+                <a:solidFill>
+                  <a:srgbClr val="EEF1F3"/>
+                </a:solidFill>
+                <a:latin typeface="Arial"/>
+              </a:rPr>
+              <a:t>unforgeable</a:t>
+            </a:r>
+          </a:p>
+        </p:txBody>
+      </p:sp>
+      <p:sp>
+        <p:nvSpPr>
+          <p:cNvPr id="22" name="Rounded Rectangle 21"/>
+          <p:cNvSpPr/>
+          <p:nvPr/>
+        </p:nvSpPr>
+        <p:spPr>
+          <a:xfrm>
+            <a:off x="502920" y="3794760"/>
+            <a:ext cx="11155680" cy="1965960"/>
           </a:xfrm>
           <a:prstGeom prst="roundRect">
             <a:avLst/>
@@ -7634,123 +8109,90 @@
       </p:sp>
       <p:sp>
         <p:nvSpPr>
-          <p:cNvPr id="11" name="TextBox 10"/>
-          <p:cNvSpPr txBox="1"/>
-          <p:nvPr/>
-        </p:nvSpPr>
-        <p:spPr>
-          <a:xfrm>
-            <a:off x="6583680" y="2148840"/>
-            <a:ext cx="4480560" cy="274320"/>
-          </a:xfrm>
-          <a:prstGeom prst="rect">
-            <a:avLst/>
-          </a:prstGeom>
-          <a:noFill/>
-        </p:spPr>
-        <p:txBody>
-          <a:bodyPr wrap="square" lIns="45720" rIns="45720" tIns="27432" bIns="27432" anchor="t">
-            <a:spAutoFit/>
-          </a:bodyPr>
-          <a:lstStyle/>
-          <a:p>
-            <a:r>
-              <a:rPr sz="1500" b="1">
+          <p:cNvPr id="23" name="TextBox 22"/>
+          <p:cNvSpPr txBox="1"/>
+          <p:nvPr/>
+        </p:nvSpPr>
+        <p:spPr>
+          <a:xfrm>
+            <a:off x="777240" y="4023360"/>
+            <a:ext cx="2011680" cy="274320"/>
+          </a:xfrm>
+          <a:prstGeom prst="rect">
+            <a:avLst/>
+          </a:prstGeom>
+          <a:noFill/>
+        </p:spPr>
+        <p:txBody>
+          <a:bodyPr wrap="square" lIns="45720" rIns="45720" tIns="27432" bIns="27432" anchor="t">
+            <a:spAutoFit/>
+          </a:bodyPr>
+          <a:lstStyle/>
+          <a:p>
+            <a:r>
+              <a:rPr sz="1400" b="1">
                 <a:solidFill>
                   <a:srgbClr val="FF6B35"/>
                 </a:solidFill>
                 <a:latin typeface="Arial"/>
               </a:rPr>
-              <a:t>NOT DONE</a:t>
-            </a:r>
-          </a:p>
-        </p:txBody>
-      </p:sp>
-      <p:sp>
-        <p:nvSpPr>
-          <p:cNvPr id="12" name="TextBox 11"/>
-          <p:cNvSpPr txBox="1"/>
-          <p:nvPr/>
-        </p:nvSpPr>
-        <p:spPr>
-          <a:xfrm>
-            <a:off x="6583680" y="2651760"/>
-            <a:ext cx="4297680" cy="2377440"/>
-          </a:xfrm>
-          <a:prstGeom prst="rect">
-            <a:avLst/>
-          </a:prstGeom>
-          <a:noFill/>
-        </p:spPr>
-        <p:txBody>
-          <a:bodyPr wrap="square" lIns="45720" rIns="45720" tIns="27432" bIns="27432" anchor="t">
-            <a:spAutoFit/>
-          </a:bodyPr>
-          <a:lstStyle/>
-          <a:p>
-            <a:r>
-              <a:rPr sz="1800" b="1">
+              <a:t>JOURNAL</a:t>
+            </a:r>
+          </a:p>
+        </p:txBody>
+      </p:sp>
+      <p:sp>
+        <p:nvSpPr>
+          <p:cNvPr id="24" name="TextBox 23"/>
+          <p:cNvSpPr txBox="1"/>
+          <p:nvPr/>
+        </p:nvSpPr>
+        <p:spPr>
+          <a:xfrm>
+            <a:off x="777240" y="4434840"/>
+            <a:ext cx="10515600" cy="1097280"/>
+          </a:xfrm>
+          <a:prstGeom prst="rect">
+            <a:avLst/>
+          </a:prstGeom>
+          <a:noFill/>
+        </p:spPr>
+        <p:txBody>
+          <a:bodyPr wrap="square" lIns="45720" rIns="45720" tIns="27432" bIns="27432" anchor="t">
+            <a:spAutoFit/>
+          </a:bodyPr>
+          <a:lstStyle/>
+          <a:p>
+            <a:r>
+              <a:rPr sz="1500" b="0">
                 <a:solidFill>
                   <a:srgbClr val="EEF1F3"/>
                 </a:solidFill>
                 <a:latin typeface="Arial"/>
               </a:rPr>
-              <a:t>Standard System / INCLUDED</a:t>
-            </a:r>
-          </a:p>
-          <a:p>
-            <a:r>
-              <a:rPr sz="1800" b="1">
+              <a:t>Record at the trap. Replay the recorded result. Do not call the original service.</a:t>
+            </a:r>
+          </a:p>
+          <a:p>
+            <a:r>
+              <a:rPr sz="1500" b="0">
                 <a:solidFill>
                   <a:srgbClr val="EEF1F3"/>
                 </a:solidFill>
                 <a:latin typeface="Arial"/>
               </a:rPr>
-              <a:t>internationalized compiler</a:t>
-            </a:r>
-          </a:p>
-          <a:p>
-            <a:r>
-              <a:rPr sz="1800" b="1">
+              <a:t>SHA-256 + HMAC with a deployment key. Sequence checkpoints, not heap snapshots.</a:t>
+            </a:r>
+          </a:p>
+          <a:p>
+            <a:r>
+              <a:rPr sz="1500" b="0">
                 <a:solidFill>
                   <a:srgbClr val="EEF1F3"/>
                 </a:solidFill>
                 <a:latin typeface="Arial"/>
               </a:rPr>
-              <a:t>GNU Emacs / a kernel</a:t>
-            </a:r>
-          </a:p>
-          <a:p>
-            <a:r>
-              <a:rPr sz="1800" b="1">
-                <a:solidFill>
-                  <a:srgbClr val="EEF1F3"/>
-                </a:solidFill>
-                <a:latin typeface="Arial"/>
-              </a:rPr>
-              <a:t>CUDA or CPython wrap</a:t>
-            </a:r>
-          </a:p>
-          <a:p>
-            <a:r>
-              <a:rPr sz="1800" b="1">
-                <a:solidFill>
-                  <a:srgbClr val="EEF1F3"/>
-                </a:solidFill>
-                <a:latin typeface="Arial"/>
-              </a:rPr>
-              <a:t>header deps (#211)</a:t>
-            </a:r>
-          </a:p>
-          <a:p>
-            <a:r>
-              <a:rPr sz="1800" b="1">
-                <a:solidFill>
-                  <a:srgbClr val="EEF1F3"/>
-                </a:solidFill>
-                <a:latin typeface="Arial"/>
-              </a:rPr>
-              <a:t>5.0 One IR</a:t>
+              <a:t>Tested C library in 4.5. Not a hook on every vm.c trap. POSIX is the host.</a:t>
             </a:r>
           </a:p>
         </p:txBody>
@@ -7816,6 +8258,536 @@
           </a:p>
         </p:txBody>
       </p:sp>
+      <p:sp>
+        <p:nvSpPr>
+          <p:cNvPr id="3" name="TextBox 2"/>
+          <p:cNvSpPr txBox="1"/>
+          <p:nvPr/>
+        </p:nvSpPr>
+        <p:spPr>
+          <a:xfrm>
+            <a:off x="594360" y="457200"/>
+            <a:ext cx="10789920" cy="640080"/>
+          </a:xfrm>
+          <a:prstGeom prst="rect">
+            <a:avLst/>
+          </a:prstGeom>
+          <a:noFill/>
+        </p:spPr>
+        <p:txBody>
+          <a:bodyPr wrap="square" lIns="45720" rIns="45720" tIns="27432" bIns="27432" anchor="t">
+            <a:spAutoFit/>
+          </a:bodyPr>
+          <a:lstStyle/>
+          <a:p>
+            <a:r>
+              <a:rPr sz="2800" b="1">
+                <a:solidFill>
+                  <a:srgbClr val="EEF1F3"/>
+                </a:solidFill>
+                <a:latin typeface="Arial"/>
+              </a:rPr>
+              <a:t>4.1–4.5 shipped. Here is what I have not done.</a:t>
+            </a:r>
+          </a:p>
+        </p:txBody>
+      </p:sp>
+      <p:sp>
+        <p:nvSpPr>
+          <p:cNvPr id="4" name="TextBox 3"/>
+          <p:cNvSpPr txBox="1"/>
+          <p:nvPr/>
+        </p:nvSpPr>
+        <p:spPr>
+          <a:xfrm>
+            <a:off x="621792" y="1170432"/>
+            <a:ext cx="10607040" cy="411480"/>
+          </a:xfrm>
+          <a:prstGeom prst="rect">
+            <a:avLst/>
+          </a:prstGeom>
+          <a:noFill/>
+        </p:spPr>
+        <p:txBody>
+          <a:bodyPr wrap="square" lIns="45720" rIns="45720" tIns="27432" bIns="27432" anchor="t">
+            <a:spAutoFit/>
+          </a:bodyPr>
+          <a:lstStyle/>
+          <a:p>
+            <a:r>
+              <a:rPr sz="1300" b="0">
+                <a:solidFill>
+                  <a:srgbClr val="72B7D6"/>
+                </a:solidFill>
+                <a:latin typeface="Arial"/>
+              </a:rPr>
+              <a:t>One public tag from v4.0.0. Five product phases, not five GitHub Releases.</a:t>
+            </a:r>
+          </a:p>
+        </p:txBody>
+      </p:sp>
+      <p:sp>
+        <p:nvSpPr>
+          <p:cNvPr id="5" name="TextBox 4"/>
+          <p:cNvSpPr txBox="1"/>
+          <p:nvPr/>
+        </p:nvSpPr>
+        <p:spPr>
+          <a:xfrm>
+            <a:off x="411480" y="6638544"/>
+            <a:ext cx="1097280" cy="137160"/>
+          </a:xfrm>
+          <a:prstGeom prst="rect">
+            <a:avLst/>
+          </a:prstGeom>
+          <a:noFill/>
+        </p:spPr>
+        <p:txBody>
+          <a:bodyPr wrap="square" lIns="45720" rIns="45720" tIns="27432" bIns="27432" anchor="t">
+            <a:spAutoFit/>
+          </a:bodyPr>
+          <a:lstStyle/>
+          <a:p>
+            <a:r>
+              <a:rPr sz="800" b="1">
+                <a:solidFill>
+                  <a:srgbClr val="65707C"/>
+                </a:solidFill>
+                <a:latin typeface="Arial"/>
+              </a:rPr>
+              <a:t>NANOLANG</a:t>
+            </a:r>
+          </a:p>
+        </p:txBody>
+      </p:sp>
+      <p:sp>
+        <p:nvSpPr>
+          <p:cNvPr id="6" name="TextBox 5"/>
+          <p:cNvSpPr txBox="1"/>
+          <p:nvPr/>
+        </p:nvSpPr>
+        <p:spPr>
+          <a:xfrm>
+            <a:off x="11567160" y="6638544"/>
+            <a:ext cx="228600" cy="137160"/>
+          </a:xfrm>
+          <a:prstGeom prst="rect">
+            <a:avLst/>
+          </a:prstGeom>
+          <a:noFill/>
+        </p:spPr>
+        <p:txBody>
+          <a:bodyPr wrap="square" lIns="45720" rIns="45720" tIns="27432" bIns="27432" anchor="t">
+            <a:spAutoFit/>
+          </a:bodyPr>
+          <a:lstStyle/>
+          <a:p>
+            <a:pPr algn="r"/>
+            <a:r>
+              <a:rPr sz="800" b="1">
+                <a:solidFill>
+                  <a:srgbClr val="65707C"/>
+                </a:solidFill>
+                <a:latin typeface="Arial"/>
+              </a:rPr>
+              <a:t>15</a:t>
+            </a:r>
+          </a:p>
+        </p:txBody>
+      </p:sp>
+      <p:sp>
+        <p:nvSpPr>
+          <p:cNvPr id="7" name="Rounded Rectangle 6"/>
+          <p:cNvSpPr/>
+          <p:nvPr/>
+        </p:nvSpPr>
+        <p:spPr>
+          <a:xfrm>
+            <a:off x="731520" y="1828800"/>
+            <a:ext cx="5166360" cy="3566160"/>
+          </a:xfrm>
+          <a:prstGeom prst="roundRect">
+            <a:avLst/>
+          </a:prstGeom>
+          <a:solidFill>
+            <a:srgbClr val="23282F"/>
+          </a:solidFill>
+          <a:ln>
+            <a:noFill/>
+          </a:ln>
+        </p:spPr>
+        <p:style>
+          <a:lnRef idx="1">
+            <a:schemeClr val="accent1"/>
+          </a:lnRef>
+          <a:fillRef idx="3">
+            <a:schemeClr val="accent1"/>
+          </a:fillRef>
+          <a:effectRef idx="2">
+            <a:schemeClr val="accent1"/>
+          </a:effectRef>
+          <a:fontRef idx="minor">
+            <a:schemeClr val="lt1"/>
+          </a:fontRef>
+        </p:style>
+        <p:txBody>
+          <a:bodyPr rtlCol="0" anchor="ctr"/>
+          <a:lstStyle/>
+          <a:p>
+            <a:pPr algn="ctr"/>
+          </a:p>
+        </p:txBody>
+      </p:sp>
+      <p:sp>
+        <p:nvSpPr>
+          <p:cNvPr id="8" name="TextBox 7"/>
+          <p:cNvSpPr txBox="1"/>
+          <p:nvPr/>
+        </p:nvSpPr>
+        <p:spPr>
+          <a:xfrm>
+            <a:off x="1005840" y="2148840"/>
+            <a:ext cx="4480560" cy="274320"/>
+          </a:xfrm>
+          <a:prstGeom prst="rect">
+            <a:avLst/>
+          </a:prstGeom>
+          <a:noFill/>
+        </p:spPr>
+        <p:txBody>
+          <a:bodyPr wrap="square" lIns="45720" rIns="45720" tIns="27432" bIns="27432" anchor="t">
+            <a:spAutoFit/>
+          </a:bodyPr>
+          <a:lstStyle/>
+          <a:p>
+            <a:r>
+              <a:rPr sz="1500" b="1">
+                <a:solidFill>
+                  <a:srgbClr val="76B900"/>
+                </a:solidFill>
+                <a:latin typeface="Arial"/>
+              </a:rPr>
+              <a:t>4.5 SHIPPED</a:t>
+            </a:r>
+          </a:p>
+        </p:txBody>
+      </p:sp>
+      <p:sp>
+        <p:nvSpPr>
+          <p:cNvPr id="9" name="TextBox 8"/>
+          <p:cNvSpPr txBox="1"/>
+          <p:nvPr/>
+        </p:nvSpPr>
+        <p:spPr>
+          <a:xfrm>
+            <a:off x="1005840" y="2651760"/>
+            <a:ext cx="4297680" cy="2377440"/>
+          </a:xfrm>
+          <a:prstGeom prst="rect">
+            <a:avLst/>
+          </a:prstGeom>
+          <a:noFill/>
+        </p:spPr>
+        <p:txBody>
+          <a:bodyPr wrap="square" lIns="45720" rIns="45720" tIns="27432" bIns="27432" anchor="t">
+            <a:spAutoFit/>
+          </a:bodyPr>
+          <a:lstStyle/>
+          <a:p>
+            <a:r>
+              <a:rPr sz="1800" b="1">
+                <a:solidFill>
+                  <a:srgbClr val="EEF1F3"/>
+                </a:solidFill>
+                <a:latin typeface="Arial"/>
+              </a:rPr>
+              <a:t>verified NanoISA v2 (4.0)</a:t>
+            </a:r>
+          </a:p>
+          <a:p>
+            <a:r>
+              <a:rPr sz="1800" b="1">
+                <a:solidFill>
+                  <a:srgbClr val="EEF1F3"/>
+                </a:solidFill>
+                <a:latin typeface="Arial"/>
+              </a:rPr>
+              <a:t>Forth Core evidence</a:t>
+            </a:r>
+          </a:p>
+          <a:p>
+            <a:r>
+              <a:rPr sz="1800" b="1">
+                <a:solidFill>
+                  <a:srgbClr val="EEF1F3"/>
+                </a:solidFill>
+                <a:latin typeface="Arial"/>
+              </a:rPr>
+              <a:t>NSI v0 + POSIX fabric</a:t>
+            </a:r>
+          </a:p>
+          <a:p>
+            <a:r>
+              <a:rPr sz="1800" b="1">
+                <a:solidFill>
+                  <a:srgbClr val="EEF1F3"/>
+                </a:solidFill>
+                <a:latin typeface="Arial"/>
+              </a:rPr>
+              <a:t>unforgeable capabilities</a:t>
+            </a:r>
+          </a:p>
+          <a:p>
+            <a:r>
+              <a:rPr sz="1800" b="1">
+                <a:solidFill>
+                  <a:srgbClr val="EEF1F3"/>
+                </a:solidFill>
+                <a:latin typeface="Arial"/>
+              </a:rPr>
+              <a:t>isolated editor walker</a:t>
+            </a:r>
+          </a:p>
+          <a:p>
+            <a:r>
+              <a:rPr sz="1800" b="1">
+                <a:solidFill>
+                  <a:srgbClr val="EEF1F3"/>
+                </a:solidFill>
+                <a:latin typeface="Arial"/>
+              </a:rPr>
+              <a:t>effects → policy + journal</a:t>
+            </a:r>
+          </a:p>
+        </p:txBody>
+      </p:sp>
+      <p:sp>
+        <p:nvSpPr>
+          <p:cNvPr id="10" name="Rounded Rectangle 9"/>
+          <p:cNvSpPr/>
+          <p:nvPr/>
+        </p:nvSpPr>
+        <p:spPr>
+          <a:xfrm>
+            <a:off x="6309360" y="1828800"/>
+            <a:ext cx="5166360" cy="3566160"/>
+          </a:xfrm>
+          <a:prstGeom prst="roundRect">
+            <a:avLst/>
+          </a:prstGeom>
+          <a:solidFill>
+            <a:srgbClr val="101317"/>
+          </a:solidFill>
+          <a:ln>
+            <a:noFill/>
+          </a:ln>
+        </p:spPr>
+        <p:style>
+          <a:lnRef idx="1">
+            <a:schemeClr val="accent1"/>
+          </a:lnRef>
+          <a:fillRef idx="3">
+            <a:schemeClr val="accent1"/>
+          </a:fillRef>
+          <a:effectRef idx="2">
+            <a:schemeClr val="accent1"/>
+          </a:effectRef>
+          <a:fontRef idx="minor">
+            <a:schemeClr val="lt1"/>
+          </a:fontRef>
+        </p:style>
+        <p:txBody>
+          <a:bodyPr rtlCol="0" anchor="ctr"/>
+          <a:lstStyle/>
+          <a:p>
+            <a:pPr algn="ctr"/>
+          </a:p>
+        </p:txBody>
+      </p:sp>
+      <p:sp>
+        <p:nvSpPr>
+          <p:cNvPr id="11" name="TextBox 10"/>
+          <p:cNvSpPr txBox="1"/>
+          <p:nvPr/>
+        </p:nvSpPr>
+        <p:spPr>
+          <a:xfrm>
+            <a:off x="6583680" y="2148840"/>
+            <a:ext cx="4480560" cy="274320"/>
+          </a:xfrm>
+          <a:prstGeom prst="rect">
+            <a:avLst/>
+          </a:prstGeom>
+          <a:noFill/>
+        </p:spPr>
+        <p:txBody>
+          <a:bodyPr wrap="square" lIns="45720" rIns="45720" tIns="27432" bIns="27432" anchor="t">
+            <a:spAutoFit/>
+          </a:bodyPr>
+          <a:lstStyle/>
+          <a:p>
+            <a:r>
+              <a:rPr sz="1500" b="1">
+                <a:solidFill>
+                  <a:srgbClr val="FF6B35"/>
+                </a:solidFill>
+                <a:latin typeface="Arial"/>
+              </a:rPr>
+              <a:t>NOT DONE</a:t>
+            </a:r>
+          </a:p>
+        </p:txBody>
+      </p:sp>
+      <p:sp>
+        <p:nvSpPr>
+          <p:cNvPr id="12" name="TextBox 11"/>
+          <p:cNvSpPr txBox="1"/>
+          <p:nvPr/>
+        </p:nvSpPr>
+        <p:spPr>
+          <a:xfrm>
+            <a:off x="6583680" y="2651760"/>
+            <a:ext cx="4297680" cy="2377440"/>
+          </a:xfrm>
+          <a:prstGeom prst="rect">
+            <a:avLst/>
+          </a:prstGeom>
+          <a:noFill/>
+        </p:spPr>
+        <p:txBody>
+          <a:bodyPr wrap="square" lIns="45720" rIns="45720" tIns="27432" bIns="27432" anchor="t">
+            <a:spAutoFit/>
+          </a:bodyPr>
+          <a:lstStyle/>
+          <a:p>
+            <a:r>
+              <a:rPr sz="1800" b="1">
+                <a:solidFill>
+                  <a:srgbClr val="EEF1F3"/>
+                </a:solidFill>
+                <a:latin typeface="Arial"/>
+              </a:rPr>
+              <a:t>Standard System / INCLUDED</a:t>
+            </a:r>
+          </a:p>
+          <a:p>
+            <a:r>
+              <a:rPr sz="1800" b="1">
+                <a:solidFill>
+                  <a:srgbClr val="EEF1F3"/>
+                </a:solidFill>
+                <a:latin typeface="Arial"/>
+              </a:rPr>
+              <a:t>internationalized compiler</a:t>
+            </a:r>
+          </a:p>
+          <a:p>
+            <a:r>
+              <a:rPr sz="1800" b="1">
+                <a:solidFill>
+                  <a:srgbClr val="EEF1F3"/>
+                </a:solidFill>
+                <a:latin typeface="Arial"/>
+              </a:rPr>
+              <a:t>GNU Emacs / a kernel</a:t>
+            </a:r>
+          </a:p>
+          <a:p>
+            <a:r>
+              <a:rPr sz="1800" b="1">
+                <a:solidFill>
+                  <a:srgbClr val="EEF1F3"/>
+                </a:solidFill>
+                <a:latin typeface="Arial"/>
+              </a:rPr>
+              <a:t>CUDA or CPython wrap</a:t>
+            </a:r>
+          </a:p>
+          <a:p>
+            <a:r>
+              <a:rPr sz="1800" b="1">
+                <a:solidFill>
+                  <a:srgbClr val="EEF1F3"/>
+                </a:solidFill>
+                <a:latin typeface="Arial"/>
+              </a:rPr>
+              <a:t>journal on every trap</a:t>
+            </a:r>
+          </a:p>
+          <a:p>
+            <a:r>
+              <a:rPr sz="1800" b="1">
+                <a:solidFill>
+                  <a:srgbClr val="EEF1F3"/>
+                </a:solidFill>
+                <a:latin typeface="Arial"/>
+              </a:rPr>
+              <a:t>5.0 One IR</a:t>
+            </a:r>
+          </a:p>
+        </p:txBody>
+      </p:sp>
+    </p:spTree>
+  </p:cSld>
+  <p:clrMapOvr>
+    <a:masterClrMapping/>
+  </p:clrMapOvr>
+</p:sld>
+</file>
+
+<file path=ppt/slides/slide16.xml><?xml version="1.0" encoding="utf-8"?>
+<p:sld xmlns:a="http://schemas.openxmlformats.org/drawingml/2006/main" xmlns:p="http://schemas.openxmlformats.org/presentationml/2006/main" xmlns:r="http://schemas.openxmlformats.org/officeDocument/2006/relationships">
+  <p:cSld>
+    <p:spTree>
+      <p:nvGrpSpPr>
+        <p:cNvPr id="1" name=""/>
+        <p:cNvGrpSpPr/>
+        <p:nvPr/>
+      </p:nvGrpSpPr>
+      <p:grpSpPr/>
+      <p:sp>
+        <p:nvSpPr>
+          <p:cNvPr id="2" name="Rectangle 1"/>
+          <p:cNvSpPr/>
+          <p:nvPr/>
+        </p:nvSpPr>
+        <p:spPr>
+          <a:xfrm>
+            <a:off x="0" y="0"/>
+            <a:ext cx="12191695" cy="6858000"/>
+          </a:xfrm>
+          <a:prstGeom prst="rect">
+            <a:avLst/>
+          </a:prstGeom>
+          <a:solidFill>
+            <a:srgbClr val="101317"/>
+          </a:solidFill>
+          <a:ln>
+            <a:noFill/>
+          </a:ln>
+        </p:spPr>
+        <p:style>
+          <a:lnRef idx="1">
+            <a:schemeClr val="accent1"/>
+          </a:lnRef>
+          <a:fillRef idx="3">
+            <a:schemeClr val="accent1"/>
+          </a:fillRef>
+          <a:effectRef idx="2">
+            <a:schemeClr val="accent1"/>
+          </a:effectRef>
+          <a:fontRef idx="minor">
+            <a:schemeClr val="lt1"/>
+          </a:fontRef>
+        </p:style>
+        <p:txBody>
+          <a:bodyPr rtlCol="0" anchor="ctr"/>
+          <a:lstStyle/>
+          <a:p>
+            <a:pPr algn="ctr"/>
+          </a:p>
+        </p:txBody>
+      </p:sp>
       <p:pic>
         <p:nvPicPr>
           <p:cNvPr id="3" name="Picture 2" descr="nanolang-mascot.png"/>
@@ -7948,7 +8920,7 @@
                 </a:solidFill>
                 <a:latin typeface="Courier New"/>
               </a:rPr>
-              <a:t>docs/RELEASE_4.4.md · docs/ROADMAP.md · docs/NSI_FABRIC.md</a:t>
+              <a:t>docs/RELEASE_4.5.md · userguide/guide/08_secure_runtime.md</a:t>
             </a:r>
           </a:p>
         </p:txBody>
@@ -8017,7 +8989,7 @@
                 </a:solidFill>
                 <a:latin typeface="Arial"/>
               </a:rPr>
-              <a:t>15</a:t>
+              <a:t>16</a:t>
             </a:r>
           </a:p>
         </p:txBody>

</xml_diff>

<commit_message>
feat: 4.1–4.5 public-release bar (docs, runtime, leftover 4.1) (#247)
* feat: close 4.1 leftover, sdl_term, and Phase 19

Publish the honest Forth 2012 label, compile the sdl_term MVP as
unsafe smoke, and land the 4.5 effects-to-policy, trap journal, and
observability library so the public cut can cover 4.1-4.5.

Related to task_6087b948f1c9a7672420b4e1ea72bd35,
task_d35028a1b27f45948ffccb351fc7bd4a,
task_2bd5c3128983683b78134ad9257b7d3b.

* docs: frame 4.1-4.5 as a language and secure runtime

The last public GitHub Release is v4.0.0. Public notes, LinkedIn draft,
developer deck, and user guide now describe v4.5.0 covering 4.1-4.5,
including NSI, capabilities, POSIX fabric, and the trap journal.

Related to task_d2f80f3c3ca6ee5f81070545a5a2ac5f.

* test: sync user-guide translation memory with English

CI requires memory.json hashes to match published English pages.
Update them after the 4.5 Secure Runtime chapter and related edits.
</commit_message>
<xml_diff>
--- a/docs/presentation/nanolang-developer-overview.pptx
+++ b/docs/presentation/nanolang-developer-overview.pptx
@@ -20,6 +20,7 @@
     <p:sldId id="268" r:id="rId20"/>
     <p:sldId id="269" r:id="rId21"/>
     <p:sldId id="270" r:id="rId22"/>
+    <p:sldId id="271" r:id="rId23"/>
   </p:sldIdLst>
   <p:sldSz cx="12191695" cy="6858000" type="screen4x3"/>
   <p:notesSz cx="6858000" cy="9144000"/>
@@ -516,7 +517,12 @@
           <a:lstStyle/>
           <a:p>
             <a:r>
-              <a:t>Authority: docs/PERSONA.md, README.md, docs/RELEASE_4.4.md.</a:t>
+              <a:t>Authority: docs/PERSONA.md, README.md, docs/RELEASE_4.5.md.</a:t>
+            </a:r>
+          </a:p>
+          <a:p>
+            <a:r>
+              <a:t>I am a language and a secure runtime. I do not claim a kernel.</a:t>
             </a:r>
           </a:p>
           <a:p>
@@ -901,17 +907,17 @@
           <a:lstStyle/>
           <a:p>
             <a:r>
-              <a:t>Authority: docs/RELEASE_4.4.md, docs/ROADMAP.md, docs/FORTH_2012.md, docs/NSI_FABRIC.md, docs/NANO_EMACS.md.</a:t>
-            </a:r>
-          </a:p>
-          <a:p>
-            <a:r>
-              <a:t>Catalogs and machine-draft guides exist. JSON/TOON stay English.</a:t>
-            </a:r>
-          </a:p>
-          <a:p>
-            <a:r>
-              <a:t>The live editor uses bin/nano_emacs_worker, not dlopen.</a:t>
+              <a:t>Authority: docs/NSI.md, docs/NSI_FABRIC.md, docs/NSI_EFFECTS.md, schema/nsi/effect_map.v0.json.</a:t>
+            </a:r>
+          </a:p>
+          <a:p>
+            <a:r>
+              <a:t>State has no host cap. Err maps to TRAP_ERROR and invents no NSI method.</a:t>
+            </a:r>
+          </a:p>
+          <a:p>
+            <a:r>
+              <a:t>I do not claim a kernel, AES, PKI, or that the journal is wired into every trap.</a:t>
             </a:r>
           </a:p>
         </p:txBody>
@@ -981,7 +987,87 @@
           <a:lstStyle/>
           <a:p>
             <a:r>
-              <a:t>Authority: CONTRIBUTING.md, docs/PERSONA.md, docs/ROADMAP.md.</a:t>
+              <a:t>Authority: docs/RELEASE_4.5.md, docs/ROADMAP.md, docs/FORTH_STANDARD_SYSTEM.md, docs/NSI_EFFECTS.md.</a:t>
+            </a:r>
+          </a:p>
+          <a:p>
+            <a:r>
+              <a:t>Catalogs and machine-draft guides exist. JSON/TOON stay English.</a:t>
+            </a:r>
+          </a:p>
+          <a:p>
+            <a:r>
+              <a:t>The live editor uses bin/nano_emacs_worker, not dlopen.</a:t>
+            </a:r>
+          </a:p>
+        </p:txBody>
+      </p:sp>
+      <p:sp>
+        <p:nvSpPr>
+          <p:cNvPr id="4" name="Slide Number Placeholder 3"/>
+          <p:cNvSpPr>
+            <a:spLocks noGrp="1"/>
+          </p:cNvSpPr>
+          <p:nvPr>
+            <p:ph type="sldNum" idx="5" sz="quarter"/>
+          </p:nvPr>
+        </p:nvSpPr>
+        <p:spPr/>
+      </p:sp>
+    </p:spTree>
+  </p:cSld>
+  <p:clrMapOvr>
+    <a:masterClrMapping/>
+  </p:clrMapOvr>
+</p:notes>
+</file>
+
+<file path=ppt/notesSlides/notesSlide16.xml><?xml version="1.0" encoding="utf-8"?>
+<p:notes xmlns:a="http://schemas.openxmlformats.org/drawingml/2006/main" xmlns:p="http://schemas.openxmlformats.org/presentationml/2006/main" xmlns:r="http://schemas.openxmlformats.org/officeDocument/2006/relationships">
+  <p:cSld>
+    <p:spTree>
+      <p:nvGrpSpPr>
+        <p:cNvPr id="1" name=""/>
+        <p:cNvGrpSpPr/>
+        <p:nvPr/>
+      </p:nvGrpSpPr>
+      <p:grpSpPr>
+        <a:xfrm>
+          <a:off x="0" y="0"/>
+          <a:ext cx="0" cy="0"/>
+          <a:chOff x="0" y="0"/>
+          <a:chExt cx="0" cy="0"/>
+        </a:xfrm>
+      </p:grpSpPr>
+      <p:sp>
+        <p:nvSpPr>
+          <p:cNvPr id="2" name="Slide Image Placeholder 1"/>
+          <p:cNvSpPr>
+            <a:spLocks noGrp="1"/>
+          </p:cNvSpPr>
+          <p:nvPr>
+            <p:ph type="sldImg" idx="2"/>
+          </p:nvPr>
+        </p:nvSpPr>
+        <p:spPr/>
+      </p:sp>
+      <p:sp>
+        <p:nvSpPr>
+          <p:cNvPr id="3" name="Notes Placeholder 2"/>
+          <p:cNvSpPr>
+            <a:spLocks noGrp="1"/>
+          </p:cNvSpPr>
+          <p:nvPr>
+            <p:ph type="body" idx="3" sz="quarter"/>
+          </p:nvPr>
+        </p:nvSpPr>
+        <p:spPr/>
+        <p:txBody>
+          <a:bodyPr/>
+          <a:lstStyle/>
+          <a:p>
+            <a:r>
+              <a:t>Authority: CONTRIBUTING.md, docs/PERSONA.md, docs/ROADMAP.md, docs/RELEASE_4.5.md.</a:t>
             </a:r>
           </a:p>
         </p:txBody>
@@ -4756,7 +4842,7 @@
                 </a:solidFill>
                 <a:latin typeface="Arial"/>
               </a:rPr>
-              <a:t>NANOLANG 4.4</a:t>
+              <a:t>NANOLANG 4.5</a:t>
             </a:r>
           </a:p>
         </p:txBody>
@@ -4857,7 +4943,7 @@
                 </a:solidFill>
                 <a:latin typeface="Arial"/>
               </a:rPr>
-              <a:t>A developer's view of my syntax, compiler, NanoISA, NanoVM, NSI, and what my verifier proves.</a:t>
+              <a:t>A developer's view of my syntax, compiler, NanoISA, and the secure runtime I host on POSIX.</a:t>
             </a:r>
           </a:p>
         </p:txBody>
@@ -4891,7 +4977,7 @@
                 </a:solidFill>
                 <a:latin typeface="Arial"/>
               </a:rPr>
-              <a:t>Verified bytecode · Forth evidence · NSI fabric · isolated editor walker</a:t>
+              <a:t>Verified bytecode · NSI · capabilities · fabric · trap journal</a:t>
             </a:r>
           </a:p>
         </p:txBody>
@@ -7258,7 +7344,7 @@
             <a:avLst/>
           </a:prstGeom>
           <a:solidFill>
-            <a:srgbClr val="101317"/>
+            <a:srgbClr val="EEF1F3"/>
           </a:solidFill>
           <a:ln>
             <a:noFill/>
@@ -7311,11 +7397,11 @@
             <a:r>
               <a:rPr sz="2800" b="1">
                 <a:solidFill>
-                  <a:srgbClr val="EEF1F3"/>
-                </a:solidFill>
-                <a:latin typeface="Arial"/>
-              </a:rPr>
-              <a:t>4.4 shipped. Here is what I have not done.</a:t>
+                  <a:srgbClr val="101317"/>
+                </a:solidFill>
+                <a:latin typeface="Arial"/>
+              </a:rPr>
+              <a:t>I host a secure runtime on an ordinary kernel.</a:t>
             </a:r>
           </a:p>
         </p:txBody>
@@ -7345,11 +7431,11 @@
             <a:r>
               <a:rPr sz="1300" b="0">
                 <a:solidFill>
-                  <a:srgbClr val="72B7D6"/>
-                </a:solidFill>
-                <a:latin typeface="Arial"/>
-              </a:rPr>
-              <a:t>One tag from v4.0.0. Product phases 4.1–4.4, not four Git tags.</a:t>
+                  <a:srgbClr val="65707C"/>
+                </a:solidFill>
+                <a:latin typeface="Arial"/>
+              </a:rPr>
+              <a:t>Contracts, capabilities, a POSIX fabric, and a journal. Five layers. Not synonyms.</a:t>
             </a:r>
           </a:p>
         </p:txBody>
@@ -7431,8 +7517,8 @@
         </p:nvSpPr>
         <p:spPr>
           <a:xfrm>
-            <a:off x="731520" y="1828800"/>
-            <a:ext cx="5166360" cy="3566160"/>
+            <a:off x="502920" y="1965960"/>
+            <a:ext cx="2103120" cy="1554480"/>
           </a:xfrm>
           <a:prstGeom prst="roundRect">
             <a:avLst/>
@@ -7474,28 +7560,28 @@
         </p:nvSpPr>
         <p:spPr>
           <a:xfrm>
-            <a:off x="1005840" y="2148840"/>
-            <a:ext cx="4480560" cy="274320"/>
-          </a:xfrm>
-          <a:prstGeom prst="rect">
-            <a:avLst/>
-          </a:prstGeom>
-          <a:noFill/>
-        </p:spPr>
-        <p:txBody>
-          <a:bodyPr wrap="square" lIns="45720" rIns="45720" tIns="27432" bIns="27432" anchor="t">
-            <a:spAutoFit/>
-          </a:bodyPr>
-          <a:lstStyle/>
-          <a:p>
-            <a:r>
-              <a:rPr sz="1500" b="1">
+            <a:off x="612648" y="2194560"/>
+            <a:ext cx="1874519" cy="320040"/>
+          </a:xfrm>
+          <a:prstGeom prst="rect">
+            <a:avLst/>
+          </a:prstGeom>
+          <a:noFill/>
+        </p:spPr>
+        <p:txBody>
+          <a:bodyPr wrap="square" lIns="45720" rIns="45720" tIns="27432" bIns="27432" anchor="t">
+            <a:spAutoFit/>
+          </a:bodyPr>
+          <a:lstStyle/>
+          <a:p>
+            <a:r>
+              <a:rPr sz="1400" b="1">
                 <a:solidFill>
                   <a:srgbClr val="76B900"/>
                 </a:solidFill>
-                <a:latin typeface="Arial"/>
-              </a:rPr>
-              <a:t>4.4 SHIPPED</a:t>
+                <a:latin typeface="Courier New"/>
+              </a:rPr>
+              <a:t>EFFECT</a:t>
             </a:r>
           </a:p>
         </p:txBody>
@@ -7508,83 +7594,28 @@
         </p:nvSpPr>
         <p:spPr>
           <a:xfrm>
-            <a:off x="1005840" y="2651760"/>
-            <a:ext cx="4297680" cy="2377440"/>
-          </a:xfrm>
-          <a:prstGeom prst="rect">
-            <a:avLst/>
-          </a:prstGeom>
-          <a:noFill/>
-        </p:spPr>
-        <p:txBody>
-          <a:bodyPr wrap="square" lIns="45720" rIns="45720" tIns="27432" bIns="27432" anchor="t">
-            <a:spAutoFit/>
-          </a:bodyPr>
-          <a:lstStyle/>
-          <a:p>
-            <a:r>
-              <a:rPr sz="1800" b="1">
+            <a:off x="612648" y="2651760"/>
+            <a:ext cx="1874519" cy="502920"/>
+          </a:xfrm>
+          <a:prstGeom prst="rect">
+            <a:avLst/>
+          </a:prstGeom>
+          <a:noFill/>
+        </p:spPr>
+        <p:txBody>
+          <a:bodyPr wrap="square" lIns="45720" rIns="45720" tIns="27432" bIns="27432" anchor="t">
+            <a:spAutoFit/>
+          </a:bodyPr>
+          <a:lstStyle/>
+          <a:p>
+            <a:r>
+              <a:rPr sz="1400" b="0">
                 <a:solidFill>
                   <a:srgbClr val="EEF1F3"/>
                 </a:solidFill>
                 <a:latin typeface="Arial"/>
               </a:rPr>
-              <a:t>verified NanoISA v2 (4.0)</a:t>
-            </a:r>
-          </a:p>
-          <a:p>
-            <a:r>
-              <a:rPr sz="1800" b="1">
-                <a:solidFill>
-                  <a:srgbClr val="EEF1F3"/>
-                </a:solidFill>
-                <a:latin typeface="Arial"/>
-              </a:rPr>
-              <a:t>Forth Core evidence</a:t>
-            </a:r>
-          </a:p>
-          <a:p>
-            <a:r>
-              <a:rPr sz="1800" b="1">
-                <a:solidFill>
-                  <a:srgbClr val="EEF1F3"/>
-                </a:solidFill>
-                <a:latin typeface="Arial"/>
-              </a:rPr>
-              <a:t>NSI v0 + POSIX fabric</a:t>
-            </a:r>
-          </a:p>
-          <a:p>
-            <a:r>
-              <a:rPr sz="1800" b="1">
-                <a:solidFill>
-                  <a:srgbClr val="EEF1F3"/>
-                </a:solidFill>
-                <a:latin typeface="Arial"/>
-              </a:rPr>
-              <a:t>unforgeable capabilities</a:t>
-            </a:r>
-          </a:p>
-          <a:p>
-            <a:r>
-              <a:rPr sz="1800" b="1">
-                <a:solidFill>
-                  <a:srgbClr val="EEF1F3"/>
-                </a:solidFill>
-                <a:latin typeface="Arial"/>
-              </a:rPr>
-              <a:t>isolated editor walker</a:t>
-            </a:r>
-          </a:p>
-          <a:p>
-            <a:r>
-              <a:rPr sz="1800" b="1">
-                <a:solidFill>
-                  <a:srgbClr val="EEF1F3"/>
-                </a:solidFill>
-                <a:latin typeface="Arial"/>
-              </a:rPr>
-              <a:t>six-language catalogs</a:t>
+              <a:t>source row</a:t>
             </a:r>
           </a:p>
         </p:txBody>
@@ -7597,8 +7628,452 @@
         </p:nvSpPr>
         <p:spPr>
           <a:xfrm>
-            <a:off x="6309360" y="1828800"/>
-            <a:ext cx="5166360" cy="3566160"/>
+            <a:off x="2788920" y="1965960"/>
+            <a:ext cx="2103120" cy="1554480"/>
+          </a:xfrm>
+          <a:prstGeom prst="roundRect">
+            <a:avLst/>
+          </a:prstGeom>
+          <a:solidFill>
+            <a:srgbClr val="23282F"/>
+          </a:solidFill>
+          <a:ln>
+            <a:noFill/>
+          </a:ln>
+        </p:spPr>
+        <p:style>
+          <a:lnRef idx="1">
+            <a:schemeClr val="accent1"/>
+          </a:lnRef>
+          <a:fillRef idx="3">
+            <a:schemeClr val="accent1"/>
+          </a:fillRef>
+          <a:effectRef idx="2">
+            <a:schemeClr val="accent1"/>
+          </a:effectRef>
+          <a:fontRef idx="minor">
+            <a:schemeClr val="lt1"/>
+          </a:fontRef>
+        </p:style>
+        <p:txBody>
+          <a:bodyPr rtlCol="0" anchor="ctr"/>
+          <a:lstStyle/>
+          <a:p>
+            <a:pPr algn="ctr"/>
+          </a:p>
+        </p:txBody>
+      </p:sp>
+      <p:sp>
+        <p:nvSpPr>
+          <p:cNvPr id="11" name="TextBox 10"/>
+          <p:cNvSpPr txBox="1"/>
+          <p:nvPr/>
+        </p:nvSpPr>
+        <p:spPr>
+          <a:xfrm>
+            <a:off x="2898648" y="2194560"/>
+            <a:ext cx="1874519" cy="320040"/>
+          </a:xfrm>
+          <a:prstGeom prst="rect">
+            <a:avLst/>
+          </a:prstGeom>
+          <a:noFill/>
+        </p:spPr>
+        <p:txBody>
+          <a:bodyPr wrap="square" lIns="45720" rIns="45720" tIns="27432" bIns="27432" anchor="t">
+            <a:spAutoFit/>
+          </a:bodyPr>
+          <a:lstStyle/>
+          <a:p>
+            <a:r>
+              <a:rPr sz="1400" b="1">
+                <a:solidFill>
+                  <a:srgbClr val="76B900"/>
+                </a:solidFill>
+                <a:latin typeface="Courier New"/>
+              </a:rPr>
+              <a:t>MANIFEST</a:t>
+            </a:r>
+          </a:p>
+        </p:txBody>
+      </p:sp>
+      <p:sp>
+        <p:nvSpPr>
+          <p:cNvPr id="12" name="TextBox 11"/>
+          <p:cNvSpPr txBox="1"/>
+          <p:nvPr/>
+        </p:nvSpPr>
+        <p:spPr>
+          <a:xfrm>
+            <a:off x="2898648" y="2651760"/>
+            <a:ext cx="1874519" cy="502920"/>
+          </a:xfrm>
+          <a:prstGeom prst="rect">
+            <a:avLst/>
+          </a:prstGeom>
+          <a:noFill/>
+        </p:spPr>
+        <p:txBody>
+          <a:bodyPr wrap="square" lIns="45720" rIns="45720" tIns="27432" bIns="27432" anchor="t">
+            <a:spAutoFit/>
+          </a:bodyPr>
+          <a:lstStyle/>
+          <a:p>
+            <a:r>
+              <a:rPr sz="1400" b="0">
+                <a:solidFill>
+                  <a:srgbClr val="EEF1F3"/>
+                </a:solidFill>
+                <a:latin typeface="Arial"/>
+              </a:rPr>
+              <a:t>required caps</a:t>
+            </a:r>
+          </a:p>
+        </p:txBody>
+      </p:sp>
+      <p:sp>
+        <p:nvSpPr>
+          <p:cNvPr id="13" name="Rounded Rectangle 12"/>
+          <p:cNvSpPr/>
+          <p:nvPr/>
+        </p:nvSpPr>
+        <p:spPr>
+          <a:xfrm>
+            <a:off x="5074920" y="1965960"/>
+            <a:ext cx="2103120" cy="1554480"/>
+          </a:xfrm>
+          <a:prstGeom prst="roundRect">
+            <a:avLst/>
+          </a:prstGeom>
+          <a:solidFill>
+            <a:srgbClr val="23282F"/>
+          </a:solidFill>
+          <a:ln>
+            <a:noFill/>
+          </a:ln>
+        </p:spPr>
+        <p:style>
+          <a:lnRef idx="1">
+            <a:schemeClr val="accent1"/>
+          </a:lnRef>
+          <a:fillRef idx="3">
+            <a:schemeClr val="accent1"/>
+          </a:fillRef>
+          <a:effectRef idx="2">
+            <a:schemeClr val="accent1"/>
+          </a:effectRef>
+          <a:fontRef idx="minor">
+            <a:schemeClr val="lt1"/>
+          </a:fontRef>
+        </p:style>
+        <p:txBody>
+          <a:bodyPr rtlCol="0" anchor="ctr"/>
+          <a:lstStyle/>
+          <a:p>
+            <a:pPr algn="ctr"/>
+          </a:p>
+        </p:txBody>
+      </p:sp>
+      <p:sp>
+        <p:nvSpPr>
+          <p:cNvPr id="14" name="TextBox 13"/>
+          <p:cNvSpPr txBox="1"/>
+          <p:nvPr/>
+        </p:nvSpPr>
+        <p:spPr>
+          <a:xfrm>
+            <a:off x="5184648" y="2194560"/>
+            <a:ext cx="1874519" cy="320040"/>
+          </a:xfrm>
+          <a:prstGeom prst="rect">
+            <a:avLst/>
+          </a:prstGeom>
+          <a:noFill/>
+        </p:spPr>
+        <p:txBody>
+          <a:bodyPr wrap="square" lIns="45720" rIns="45720" tIns="27432" bIns="27432" anchor="t">
+            <a:spAutoFit/>
+          </a:bodyPr>
+          <a:lstStyle/>
+          <a:p>
+            <a:r>
+              <a:rPr sz="1400" b="1">
+                <a:solidFill>
+                  <a:srgbClr val="76B900"/>
+                </a:solidFill>
+                <a:latin typeface="Courier New"/>
+              </a:rPr>
+              <a:t>TRAP</a:t>
+            </a:r>
+          </a:p>
+        </p:txBody>
+      </p:sp>
+      <p:sp>
+        <p:nvSpPr>
+          <p:cNvPr id="15" name="TextBox 14"/>
+          <p:cNvSpPr txBox="1"/>
+          <p:nvPr/>
+        </p:nvSpPr>
+        <p:spPr>
+          <a:xfrm>
+            <a:off x="5184648" y="2651760"/>
+            <a:ext cx="1874519" cy="502920"/>
+          </a:xfrm>
+          <a:prstGeom prst="rect">
+            <a:avLst/>
+          </a:prstGeom>
+          <a:noFill/>
+        </p:spPr>
+        <p:txBody>
+          <a:bodyPr wrap="square" lIns="45720" rIns="45720" tIns="27432" bIns="27432" anchor="t">
+            <a:spAutoFit/>
+          </a:bodyPr>
+          <a:lstStyle/>
+          <a:p>
+            <a:r>
+              <a:rPr sz="1400" b="0">
+                <a:solidFill>
+                  <a:srgbClr val="EEF1F3"/>
+                </a:solidFill>
+                <a:latin typeface="Arial"/>
+              </a:rPr>
+              <a:t>NanoISA</a:t>
+            </a:r>
+          </a:p>
+        </p:txBody>
+      </p:sp>
+      <p:sp>
+        <p:nvSpPr>
+          <p:cNvPr id="16" name="Rounded Rectangle 15"/>
+          <p:cNvSpPr/>
+          <p:nvPr/>
+        </p:nvSpPr>
+        <p:spPr>
+          <a:xfrm>
+            <a:off x="7360920" y="1965960"/>
+            <a:ext cx="2103120" cy="1554480"/>
+          </a:xfrm>
+          <a:prstGeom prst="roundRect">
+            <a:avLst/>
+          </a:prstGeom>
+          <a:solidFill>
+            <a:srgbClr val="23282F"/>
+          </a:solidFill>
+          <a:ln>
+            <a:noFill/>
+          </a:ln>
+        </p:spPr>
+        <p:style>
+          <a:lnRef idx="1">
+            <a:schemeClr val="accent1"/>
+          </a:lnRef>
+          <a:fillRef idx="3">
+            <a:schemeClr val="accent1"/>
+          </a:fillRef>
+          <a:effectRef idx="2">
+            <a:schemeClr val="accent1"/>
+          </a:effectRef>
+          <a:fontRef idx="minor">
+            <a:schemeClr val="lt1"/>
+          </a:fontRef>
+        </p:style>
+        <p:txBody>
+          <a:bodyPr rtlCol="0" anchor="ctr"/>
+          <a:lstStyle/>
+          <a:p>
+            <a:pPr algn="ctr"/>
+          </a:p>
+        </p:txBody>
+      </p:sp>
+      <p:sp>
+        <p:nvSpPr>
+          <p:cNvPr id="17" name="TextBox 16"/>
+          <p:cNvSpPr txBox="1"/>
+          <p:nvPr/>
+        </p:nvSpPr>
+        <p:spPr>
+          <a:xfrm>
+            <a:off x="7470648" y="2194560"/>
+            <a:ext cx="1874519" cy="320040"/>
+          </a:xfrm>
+          <a:prstGeom prst="rect">
+            <a:avLst/>
+          </a:prstGeom>
+          <a:noFill/>
+        </p:spPr>
+        <p:txBody>
+          <a:bodyPr wrap="square" lIns="45720" rIns="45720" tIns="27432" bIns="27432" anchor="t">
+            <a:spAutoFit/>
+          </a:bodyPr>
+          <a:lstStyle/>
+          <a:p>
+            <a:r>
+              <a:rPr sz="1400" b="1">
+                <a:solidFill>
+                  <a:srgbClr val="76B900"/>
+                </a:solidFill>
+                <a:latin typeface="Courier New"/>
+              </a:rPr>
+              <a:t>NSI</a:t>
+            </a:r>
+          </a:p>
+        </p:txBody>
+      </p:sp>
+      <p:sp>
+        <p:nvSpPr>
+          <p:cNvPr id="18" name="TextBox 17"/>
+          <p:cNvSpPr txBox="1"/>
+          <p:nvPr/>
+        </p:nvSpPr>
+        <p:spPr>
+          <a:xfrm>
+            <a:off x="7470648" y="2651760"/>
+            <a:ext cx="1874519" cy="502920"/>
+          </a:xfrm>
+          <a:prstGeom prst="rect">
+            <a:avLst/>
+          </a:prstGeom>
+          <a:noFill/>
+        </p:spPr>
+        <p:txBody>
+          <a:bodyPr wrap="square" lIns="45720" rIns="45720" tIns="27432" bIns="27432" anchor="t">
+            <a:spAutoFit/>
+          </a:bodyPr>
+          <a:lstStyle/>
+          <a:p>
+            <a:r>
+              <a:rPr sz="1400" b="0">
+                <a:solidFill>
+                  <a:srgbClr val="EEF1F3"/>
+                </a:solidFill>
+                <a:latin typeface="Arial"/>
+              </a:rPr>
+              <a:t>method id</a:t>
+            </a:r>
+          </a:p>
+        </p:txBody>
+      </p:sp>
+      <p:sp>
+        <p:nvSpPr>
+          <p:cNvPr id="19" name="Rounded Rectangle 18"/>
+          <p:cNvSpPr/>
+          <p:nvPr/>
+        </p:nvSpPr>
+        <p:spPr>
+          <a:xfrm>
+            <a:off x="9646920" y="1965960"/>
+            <a:ext cx="2103120" cy="1554480"/>
+          </a:xfrm>
+          <a:prstGeom prst="roundRect">
+            <a:avLst/>
+          </a:prstGeom>
+          <a:solidFill>
+            <a:srgbClr val="23282F"/>
+          </a:solidFill>
+          <a:ln>
+            <a:noFill/>
+          </a:ln>
+        </p:spPr>
+        <p:style>
+          <a:lnRef idx="1">
+            <a:schemeClr val="accent1"/>
+          </a:lnRef>
+          <a:fillRef idx="3">
+            <a:schemeClr val="accent1"/>
+          </a:fillRef>
+          <a:effectRef idx="2">
+            <a:schemeClr val="accent1"/>
+          </a:effectRef>
+          <a:fontRef idx="minor">
+            <a:schemeClr val="lt1"/>
+          </a:fontRef>
+        </p:style>
+        <p:txBody>
+          <a:bodyPr rtlCol="0" anchor="ctr"/>
+          <a:lstStyle/>
+          <a:p>
+            <a:pPr algn="ctr"/>
+          </a:p>
+        </p:txBody>
+      </p:sp>
+      <p:sp>
+        <p:nvSpPr>
+          <p:cNvPr id="20" name="TextBox 19"/>
+          <p:cNvSpPr txBox="1"/>
+          <p:nvPr/>
+        </p:nvSpPr>
+        <p:spPr>
+          <a:xfrm>
+            <a:off x="9756648" y="2194560"/>
+            <a:ext cx="1874519" cy="320040"/>
+          </a:xfrm>
+          <a:prstGeom prst="rect">
+            <a:avLst/>
+          </a:prstGeom>
+          <a:noFill/>
+        </p:spPr>
+        <p:txBody>
+          <a:bodyPr wrap="square" lIns="45720" rIns="45720" tIns="27432" bIns="27432" anchor="t">
+            <a:spAutoFit/>
+          </a:bodyPr>
+          <a:lstStyle/>
+          <a:p>
+            <a:r>
+              <a:rPr sz="1400" b="1">
+                <a:solidFill>
+                  <a:srgbClr val="76B900"/>
+                </a:solidFill>
+                <a:latin typeface="Courier New"/>
+              </a:rPr>
+              <a:t>CAP</a:t>
+            </a:r>
+          </a:p>
+        </p:txBody>
+      </p:sp>
+      <p:sp>
+        <p:nvSpPr>
+          <p:cNvPr id="21" name="TextBox 20"/>
+          <p:cNvSpPr txBox="1"/>
+          <p:nvPr/>
+        </p:nvSpPr>
+        <p:spPr>
+          <a:xfrm>
+            <a:off x="9756648" y="2651760"/>
+            <a:ext cx="1874519" cy="502920"/>
+          </a:xfrm>
+          <a:prstGeom prst="rect">
+            <a:avLst/>
+          </a:prstGeom>
+          <a:noFill/>
+        </p:spPr>
+        <p:txBody>
+          <a:bodyPr wrap="square" lIns="45720" rIns="45720" tIns="27432" bIns="27432" anchor="t">
+            <a:spAutoFit/>
+          </a:bodyPr>
+          <a:lstStyle/>
+          <a:p>
+            <a:r>
+              <a:rPr sz="1400" b="0">
+                <a:solidFill>
+                  <a:srgbClr val="EEF1F3"/>
+                </a:solidFill>
+                <a:latin typeface="Arial"/>
+              </a:rPr>
+              <a:t>unforgeable</a:t>
+            </a:r>
+          </a:p>
+        </p:txBody>
+      </p:sp>
+      <p:sp>
+        <p:nvSpPr>
+          <p:cNvPr id="22" name="Rounded Rectangle 21"/>
+          <p:cNvSpPr/>
+          <p:nvPr/>
+        </p:nvSpPr>
+        <p:spPr>
+          <a:xfrm>
+            <a:off x="502920" y="3794760"/>
+            <a:ext cx="11155680" cy="1965960"/>
           </a:xfrm>
           <a:prstGeom prst="roundRect">
             <a:avLst/>
@@ -7634,123 +8109,90 @@
       </p:sp>
       <p:sp>
         <p:nvSpPr>
-          <p:cNvPr id="11" name="TextBox 10"/>
-          <p:cNvSpPr txBox="1"/>
-          <p:nvPr/>
-        </p:nvSpPr>
-        <p:spPr>
-          <a:xfrm>
-            <a:off x="6583680" y="2148840"/>
-            <a:ext cx="4480560" cy="274320"/>
-          </a:xfrm>
-          <a:prstGeom prst="rect">
-            <a:avLst/>
-          </a:prstGeom>
-          <a:noFill/>
-        </p:spPr>
-        <p:txBody>
-          <a:bodyPr wrap="square" lIns="45720" rIns="45720" tIns="27432" bIns="27432" anchor="t">
-            <a:spAutoFit/>
-          </a:bodyPr>
-          <a:lstStyle/>
-          <a:p>
-            <a:r>
-              <a:rPr sz="1500" b="1">
+          <p:cNvPr id="23" name="TextBox 22"/>
+          <p:cNvSpPr txBox="1"/>
+          <p:nvPr/>
+        </p:nvSpPr>
+        <p:spPr>
+          <a:xfrm>
+            <a:off x="777240" y="4023360"/>
+            <a:ext cx="2011680" cy="274320"/>
+          </a:xfrm>
+          <a:prstGeom prst="rect">
+            <a:avLst/>
+          </a:prstGeom>
+          <a:noFill/>
+        </p:spPr>
+        <p:txBody>
+          <a:bodyPr wrap="square" lIns="45720" rIns="45720" tIns="27432" bIns="27432" anchor="t">
+            <a:spAutoFit/>
+          </a:bodyPr>
+          <a:lstStyle/>
+          <a:p>
+            <a:r>
+              <a:rPr sz="1400" b="1">
                 <a:solidFill>
                   <a:srgbClr val="FF6B35"/>
                 </a:solidFill>
                 <a:latin typeface="Arial"/>
               </a:rPr>
-              <a:t>NOT DONE</a:t>
-            </a:r>
-          </a:p>
-        </p:txBody>
-      </p:sp>
-      <p:sp>
-        <p:nvSpPr>
-          <p:cNvPr id="12" name="TextBox 11"/>
-          <p:cNvSpPr txBox="1"/>
-          <p:nvPr/>
-        </p:nvSpPr>
-        <p:spPr>
-          <a:xfrm>
-            <a:off x="6583680" y="2651760"/>
-            <a:ext cx="4297680" cy="2377440"/>
-          </a:xfrm>
-          <a:prstGeom prst="rect">
-            <a:avLst/>
-          </a:prstGeom>
-          <a:noFill/>
-        </p:spPr>
-        <p:txBody>
-          <a:bodyPr wrap="square" lIns="45720" rIns="45720" tIns="27432" bIns="27432" anchor="t">
-            <a:spAutoFit/>
-          </a:bodyPr>
-          <a:lstStyle/>
-          <a:p>
-            <a:r>
-              <a:rPr sz="1800" b="1">
+              <a:t>JOURNAL</a:t>
+            </a:r>
+          </a:p>
+        </p:txBody>
+      </p:sp>
+      <p:sp>
+        <p:nvSpPr>
+          <p:cNvPr id="24" name="TextBox 23"/>
+          <p:cNvSpPr txBox="1"/>
+          <p:nvPr/>
+        </p:nvSpPr>
+        <p:spPr>
+          <a:xfrm>
+            <a:off x="777240" y="4434840"/>
+            <a:ext cx="10515600" cy="1097280"/>
+          </a:xfrm>
+          <a:prstGeom prst="rect">
+            <a:avLst/>
+          </a:prstGeom>
+          <a:noFill/>
+        </p:spPr>
+        <p:txBody>
+          <a:bodyPr wrap="square" lIns="45720" rIns="45720" tIns="27432" bIns="27432" anchor="t">
+            <a:spAutoFit/>
+          </a:bodyPr>
+          <a:lstStyle/>
+          <a:p>
+            <a:r>
+              <a:rPr sz="1500" b="0">
                 <a:solidFill>
                   <a:srgbClr val="EEF1F3"/>
                 </a:solidFill>
                 <a:latin typeface="Arial"/>
               </a:rPr>
-              <a:t>Standard System / INCLUDED</a:t>
-            </a:r>
-          </a:p>
-          <a:p>
-            <a:r>
-              <a:rPr sz="1800" b="1">
+              <a:t>Record at the trap. Replay the recorded result. Do not call the original service.</a:t>
+            </a:r>
+          </a:p>
+          <a:p>
+            <a:r>
+              <a:rPr sz="1500" b="0">
                 <a:solidFill>
                   <a:srgbClr val="EEF1F3"/>
                 </a:solidFill>
                 <a:latin typeface="Arial"/>
               </a:rPr>
-              <a:t>internationalized compiler</a:t>
-            </a:r>
-          </a:p>
-          <a:p>
-            <a:r>
-              <a:rPr sz="1800" b="1">
+              <a:t>SHA-256 + HMAC with a deployment key. Sequence checkpoints, not heap snapshots.</a:t>
+            </a:r>
+          </a:p>
+          <a:p>
+            <a:r>
+              <a:rPr sz="1500" b="0">
                 <a:solidFill>
                   <a:srgbClr val="EEF1F3"/>
                 </a:solidFill>
                 <a:latin typeface="Arial"/>
               </a:rPr>
-              <a:t>GNU Emacs / a kernel</a:t>
-            </a:r>
-          </a:p>
-          <a:p>
-            <a:r>
-              <a:rPr sz="1800" b="1">
-                <a:solidFill>
-                  <a:srgbClr val="EEF1F3"/>
-                </a:solidFill>
-                <a:latin typeface="Arial"/>
-              </a:rPr>
-              <a:t>CUDA or CPython wrap</a:t>
-            </a:r>
-          </a:p>
-          <a:p>
-            <a:r>
-              <a:rPr sz="1800" b="1">
-                <a:solidFill>
-                  <a:srgbClr val="EEF1F3"/>
-                </a:solidFill>
-                <a:latin typeface="Arial"/>
-              </a:rPr>
-              <a:t>header deps (#211)</a:t>
-            </a:r>
-          </a:p>
-          <a:p>
-            <a:r>
-              <a:rPr sz="1800" b="1">
-                <a:solidFill>
-                  <a:srgbClr val="EEF1F3"/>
-                </a:solidFill>
-                <a:latin typeface="Arial"/>
-              </a:rPr>
-              <a:t>5.0 One IR</a:t>
+              <a:t>Tested C library in 4.5. Not a hook on every vm.c trap. POSIX is the host.</a:t>
             </a:r>
           </a:p>
         </p:txBody>
@@ -7816,6 +8258,536 @@
           </a:p>
         </p:txBody>
       </p:sp>
+      <p:sp>
+        <p:nvSpPr>
+          <p:cNvPr id="3" name="TextBox 2"/>
+          <p:cNvSpPr txBox="1"/>
+          <p:nvPr/>
+        </p:nvSpPr>
+        <p:spPr>
+          <a:xfrm>
+            <a:off x="594360" y="457200"/>
+            <a:ext cx="10789920" cy="640080"/>
+          </a:xfrm>
+          <a:prstGeom prst="rect">
+            <a:avLst/>
+          </a:prstGeom>
+          <a:noFill/>
+        </p:spPr>
+        <p:txBody>
+          <a:bodyPr wrap="square" lIns="45720" rIns="45720" tIns="27432" bIns="27432" anchor="t">
+            <a:spAutoFit/>
+          </a:bodyPr>
+          <a:lstStyle/>
+          <a:p>
+            <a:r>
+              <a:rPr sz="2800" b="1">
+                <a:solidFill>
+                  <a:srgbClr val="EEF1F3"/>
+                </a:solidFill>
+                <a:latin typeface="Arial"/>
+              </a:rPr>
+              <a:t>4.1–4.5 shipped. Here is what I have not done.</a:t>
+            </a:r>
+          </a:p>
+        </p:txBody>
+      </p:sp>
+      <p:sp>
+        <p:nvSpPr>
+          <p:cNvPr id="4" name="TextBox 3"/>
+          <p:cNvSpPr txBox="1"/>
+          <p:nvPr/>
+        </p:nvSpPr>
+        <p:spPr>
+          <a:xfrm>
+            <a:off x="621792" y="1170432"/>
+            <a:ext cx="10607040" cy="411480"/>
+          </a:xfrm>
+          <a:prstGeom prst="rect">
+            <a:avLst/>
+          </a:prstGeom>
+          <a:noFill/>
+        </p:spPr>
+        <p:txBody>
+          <a:bodyPr wrap="square" lIns="45720" rIns="45720" tIns="27432" bIns="27432" anchor="t">
+            <a:spAutoFit/>
+          </a:bodyPr>
+          <a:lstStyle/>
+          <a:p>
+            <a:r>
+              <a:rPr sz="1300" b="0">
+                <a:solidFill>
+                  <a:srgbClr val="72B7D6"/>
+                </a:solidFill>
+                <a:latin typeface="Arial"/>
+              </a:rPr>
+              <a:t>One public tag from v4.0.0. Five product phases, not five GitHub Releases.</a:t>
+            </a:r>
+          </a:p>
+        </p:txBody>
+      </p:sp>
+      <p:sp>
+        <p:nvSpPr>
+          <p:cNvPr id="5" name="TextBox 4"/>
+          <p:cNvSpPr txBox="1"/>
+          <p:nvPr/>
+        </p:nvSpPr>
+        <p:spPr>
+          <a:xfrm>
+            <a:off x="411480" y="6638544"/>
+            <a:ext cx="1097280" cy="137160"/>
+          </a:xfrm>
+          <a:prstGeom prst="rect">
+            <a:avLst/>
+          </a:prstGeom>
+          <a:noFill/>
+        </p:spPr>
+        <p:txBody>
+          <a:bodyPr wrap="square" lIns="45720" rIns="45720" tIns="27432" bIns="27432" anchor="t">
+            <a:spAutoFit/>
+          </a:bodyPr>
+          <a:lstStyle/>
+          <a:p>
+            <a:r>
+              <a:rPr sz="800" b="1">
+                <a:solidFill>
+                  <a:srgbClr val="65707C"/>
+                </a:solidFill>
+                <a:latin typeface="Arial"/>
+              </a:rPr>
+              <a:t>NANOLANG</a:t>
+            </a:r>
+          </a:p>
+        </p:txBody>
+      </p:sp>
+      <p:sp>
+        <p:nvSpPr>
+          <p:cNvPr id="6" name="TextBox 5"/>
+          <p:cNvSpPr txBox="1"/>
+          <p:nvPr/>
+        </p:nvSpPr>
+        <p:spPr>
+          <a:xfrm>
+            <a:off x="11567160" y="6638544"/>
+            <a:ext cx="228600" cy="137160"/>
+          </a:xfrm>
+          <a:prstGeom prst="rect">
+            <a:avLst/>
+          </a:prstGeom>
+          <a:noFill/>
+        </p:spPr>
+        <p:txBody>
+          <a:bodyPr wrap="square" lIns="45720" rIns="45720" tIns="27432" bIns="27432" anchor="t">
+            <a:spAutoFit/>
+          </a:bodyPr>
+          <a:lstStyle/>
+          <a:p>
+            <a:pPr algn="r"/>
+            <a:r>
+              <a:rPr sz="800" b="1">
+                <a:solidFill>
+                  <a:srgbClr val="65707C"/>
+                </a:solidFill>
+                <a:latin typeface="Arial"/>
+              </a:rPr>
+              <a:t>15</a:t>
+            </a:r>
+          </a:p>
+        </p:txBody>
+      </p:sp>
+      <p:sp>
+        <p:nvSpPr>
+          <p:cNvPr id="7" name="Rounded Rectangle 6"/>
+          <p:cNvSpPr/>
+          <p:nvPr/>
+        </p:nvSpPr>
+        <p:spPr>
+          <a:xfrm>
+            <a:off x="731520" y="1828800"/>
+            <a:ext cx="5166360" cy="3566160"/>
+          </a:xfrm>
+          <a:prstGeom prst="roundRect">
+            <a:avLst/>
+          </a:prstGeom>
+          <a:solidFill>
+            <a:srgbClr val="23282F"/>
+          </a:solidFill>
+          <a:ln>
+            <a:noFill/>
+          </a:ln>
+        </p:spPr>
+        <p:style>
+          <a:lnRef idx="1">
+            <a:schemeClr val="accent1"/>
+          </a:lnRef>
+          <a:fillRef idx="3">
+            <a:schemeClr val="accent1"/>
+          </a:fillRef>
+          <a:effectRef idx="2">
+            <a:schemeClr val="accent1"/>
+          </a:effectRef>
+          <a:fontRef idx="minor">
+            <a:schemeClr val="lt1"/>
+          </a:fontRef>
+        </p:style>
+        <p:txBody>
+          <a:bodyPr rtlCol="0" anchor="ctr"/>
+          <a:lstStyle/>
+          <a:p>
+            <a:pPr algn="ctr"/>
+          </a:p>
+        </p:txBody>
+      </p:sp>
+      <p:sp>
+        <p:nvSpPr>
+          <p:cNvPr id="8" name="TextBox 7"/>
+          <p:cNvSpPr txBox="1"/>
+          <p:nvPr/>
+        </p:nvSpPr>
+        <p:spPr>
+          <a:xfrm>
+            <a:off x="1005840" y="2148840"/>
+            <a:ext cx="4480560" cy="274320"/>
+          </a:xfrm>
+          <a:prstGeom prst="rect">
+            <a:avLst/>
+          </a:prstGeom>
+          <a:noFill/>
+        </p:spPr>
+        <p:txBody>
+          <a:bodyPr wrap="square" lIns="45720" rIns="45720" tIns="27432" bIns="27432" anchor="t">
+            <a:spAutoFit/>
+          </a:bodyPr>
+          <a:lstStyle/>
+          <a:p>
+            <a:r>
+              <a:rPr sz="1500" b="1">
+                <a:solidFill>
+                  <a:srgbClr val="76B900"/>
+                </a:solidFill>
+                <a:latin typeface="Arial"/>
+              </a:rPr>
+              <a:t>4.5 SHIPPED</a:t>
+            </a:r>
+          </a:p>
+        </p:txBody>
+      </p:sp>
+      <p:sp>
+        <p:nvSpPr>
+          <p:cNvPr id="9" name="TextBox 8"/>
+          <p:cNvSpPr txBox="1"/>
+          <p:nvPr/>
+        </p:nvSpPr>
+        <p:spPr>
+          <a:xfrm>
+            <a:off x="1005840" y="2651760"/>
+            <a:ext cx="4297680" cy="2377440"/>
+          </a:xfrm>
+          <a:prstGeom prst="rect">
+            <a:avLst/>
+          </a:prstGeom>
+          <a:noFill/>
+        </p:spPr>
+        <p:txBody>
+          <a:bodyPr wrap="square" lIns="45720" rIns="45720" tIns="27432" bIns="27432" anchor="t">
+            <a:spAutoFit/>
+          </a:bodyPr>
+          <a:lstStyle/>
+          <a:p>
+            <a:r>
+              <a:rPr sz="1800" b="1">
+                <a:solidFill>
+                  <a:srgbClr val="EEF1F3"/>
+                </a:solidFill>
+                <a:latin typeface="Arial"/>
+              </a:rPr>
+              <a:t>verified NanoISA v2 (4.0)</a:t>
+            </a:r>
+          </a:p>
+          <a:p>
+            <a:r>
+              <a:rPr sz="1800" b="1">
+                <a:solidFill>
+                  <a:srgbClr val="EEF1F3"/>
+                </a:solidFill>
+                <a:latin typeface="Arial"/>
+              </a:rPr>
+              <a:t>Forth Core evidence</a:t>
+            </a:r>
+          </a:p>
+          <a:p>
+            <a:r>
+              <a:rPr sz="1800" b="1">
+                <a:solidFill>
+                  <a:srgbClr val="EEF1F3"/>
+                </a:solidFill>
+                <a:latin typeface="Arial"/>
+              </a:rPr>
+              <a:t>NSI v0 + POSIX fabric</a:t>
+            </a:r>
+          </a:p>
+          <a:p>
+            <a:r>
+              <a:rPr sz="1800" b="1">
+                <a:solidFill>
+                  <a:srgbClr val="EEF1F3"/>
+                </a:solidFill>
+                <a:latin typeface="Arial"/>
+              </a:rPr>
+              <a:t>unforgeable capabilities</a:t>
+            </a:r>
+          </a:p>
+          <a:p>
+            <a:r>
+              <a:rPr sz="1800" b="1">
+                <a:solidFill>
+                  <a:srgbClr val="EEF1F3"/>
+                </a:solidFill>
+                <a:latin typeface="Arial"/>
+              </a:rPr>
+              <a:t>isolated editor walker</a:t>
+            </a:r>
+          </a:p>
+          <a:p>
+            <a:r>
+              <a:rPr sz="1800" b="1">
+                <a:solidFill>
+                  <a:srgbClr val="EEF1F3"/>
+                </a:solidFill>
+                <a:latin typeface="Arial"/>
+              </a:rPr>
+              <a:t>effects → policy + journal</a:t>
+            </a:r>
+          </a:p>
+        </p:txBody>
+      </p:sp>
+      <p:sp>
+        <p:nvSpPr>
+          <p:cNvPr id="10" name="Rounded Rectangle 9"/>
+          <p:cNvSpPr/>
+          <p:nvPr/>
+        </p:nvSpPr>
+        <p:spPr>
+          <a:xfrm>
+            <a:off x="6309360" y="1828800"/>
+            <a:ext cx="5166360" cy="3566160"/>
+          </a:xfrm>
+          <a:prstGeom prst="roundRect">
+            <a:avLst/>
+          </a:prstGeom>
+          <a:solidFill>
+            <a:srgbClr val="101317"/>
+          </a:solidFill>
+          <a:ln>
+            <a:noFill/>
+          </a:ln>
+        </p:spPr>
+        <p:style>
+          <a:lnRef idx="1">
+            <a:schemeClr val="accent1"/>
+          </a:lnRef>
+          <a:fillRef idx="3">
+            <a:schemeClr val="accent1"/>
+          </a:fillRef>
+          <a:effectRef idx="2">
+            <a:schemeClr val="accent1"/>
+          </a:effectRef>
+          <a:fontRef idx="minor">
+            <a:schemeClr val="lt1"/>
+          </a:fontRef>
+        </p:style>
+        <p:txBody>
+          <a:bodyPr rtlCol="0" anchor="ctr"/>
+          <a:lstStyle/>
+          <a:p>
+            <a:pPr algn="ctr"/>
+          </a:p>
+        </p:txBody>
+      </p:sp>
+      <p:sp>
+        <p:nvSpPr>
+          <p:cNvPr id="11" name="TextBox 10"/>
+          <p:cNvSpPr txBox="1"/>
+          <p:nvPr/>
+        </p:nvSpPr>
+        <p:spPr>
+          <a:xfrm>
+            <a:off x="6583680" y="2148840"/>
+            <a:ext cx="4480560" cy="274320"/>
+          </a:xfrm>
+          <a:prstGeom prst="rect">
+            <a:avLst/>
+          </a:prstGeom>
+          <a:noFill/>
+        </p:spPr>
+        <p:txBody>
+          <a:bodyPr wrap="square" lIns="45720" rIns="45720" tIns="27432" bIns="27432" anchor="t">
+            <a:spAutoFit/>
+          </a:bodyPr>
+          <a:lstStyle/>
+          <a:p>
+            <a:r>
+              <a:rPr sz="1500" b="1">
+                <a:solidFill>
+                  <a:srgbClr val="FF6B35"/>
+                </a:solidFill>
+                <a:latin typeface="Arial"/>
+              </a:rPr>
+              <a:t>NOT DONE</a:t>
+            </a:r>
+          </a:p>
+        </p:txBody>
+      </p:sp>
+      <p:sp>
+        <p:nvSpPr>
+          <p:cNvPr id="12" name="TextBox 11"/>
+          <p:cNvSpPr txBox="1"/>
+          <p:nvPr/>
+        </p:nvSpPr>
+        <p:spPr>
+          <a:xfrm>
+            <a:off x="6583680" y="2651760"/>
+            <a:ext cx="4297680" cy="2377440"/>
+          </a:xfrm>
+          <a:prstGeom prst="rect">
+            <a:avLst/>
+          </a:prstGeom>
+          <a:noFill/>
+        </p:spPr>
+        <p:txBody>
+          <a:bodyPr wrap="square" lIns="45720" rIns="45720" tIns="27432" bIns="27432" anchor="t">
+            <a:spAutoFit/>
+          </a:bodyPr>
+          <a:lstStyle/>
+          <a:p>
+            <a:r>
+              <a:rPr sz="1800" b="1">
+                <a:solidFill>
+                  <a:srgbClr val="EEF1F3"/>
+                </a:solidFill>
+                <a:latin typeface="Arial"/>
+              </a:rPr>
+              <a:t>Standard System / INCLUDED</a:t>
+            </a:r>
+          </a:p>
+          <a:p>
+            <a:r>
+              <a:rPr sz="1800" b="1">
+                <a:solidFill>
+                  <a:srgbClr val="EEF1F3"/>
+                </a:solidFill>
+                <a:latin typeface="Arial"/>
+              </a:rPr>
+              <a:t>internationalized compiler</a:t>
+            </a:r>
+          </a:p>
+          <a:p>
+            <a:r>
+              <a:rPr sz="1800" b="1">
+                <a:solidFill>
+                  <a:srgbClr val="EEF1F3"/>
+                </a:solidFill>
+                <a:latin typeface="Arial"/>
+              </a:rPr>
+              <a:t>GNU Emacs / a kernel</a:t>
+            </a:r>
+          </a:p>
+          <a:p>
+            <a:r>
+              <a:rPr sz="1800" b="1">
+                <a:solidFill>
+                  <a:srgbClr val="EEF1F3"/>
+                </a:solidFill>
+                <a:latin typeface="Arial"/>
+              </a:rPr>
+              <a:t>CUDA or CPython wrap</a:t>
+            </a:r>
+          </a:p>
+          <a:p>
+            <a:r>
+              <a:rPr sz="1800" b="1">
+                <a:solidFill>
+                  <a:srgbClr val="EEF1F3"/>
+                </a:solidFill>
+                <a:latin typeface="Arial"/>
+              </a:rPr>
+              <a:t>journal on every trap</a:t>
+            </a:r>
+          </a:p>
+          <a:p>
+            <a:r>
+              <a:rPr sz="1800" b="1">
+                <a:solidFill>
+                  <a:srgbClr val="EEF1F3"/>
+                </a:solidFill>
+                <a:latin typeface="Arial"/>
+              </a:rPr>
+              <a:t>5.0 One IR</a:t>
+            </a:r>
+          </a:p>
+        </p:txBody>
+      </p:sp>
+    </p:spTree>
+  </p:cSld>
+  <p:clrMapOvr>
+    <a:masterClrMapping/>
+  </p:clrMapOvr>
+</p:sld>
+</file>
+
+<file path=ppt/slides/slide16.xml><?xml version="1.0" encoding="utf-8"?>
+<p:sld xmlns:a="http://schemas.openxmlformats.org/drawingml/2006/main" xmlns:p="http://schemas.openxmlformats.org/presentationml/2006/main" xmlns:r="http://schemas.openxmlformats.org/officeDocument/2006/relationships">
+  <p:cSld>
+    <p:spTree>
+      <p:nvGrpSpPr>
+        <p:cNvPr id="1" name=""/>
+        <p:cNvGrpSpPr/>
+        <p:nvPr/>
+      </p:nvGrpSpPr>
+      <p:grpSpPr/>
+      <p:sp>
+        <p:nvSpPr>
+          <p:cNvPr id="2" name="Rectangle 1"/>
+          <p:cNvSpPr/>
+          <p:nvPr/>
+        </p:nvSpPr>
+        <p:spPr>
+          <a:xfrm>
+            <a:off x="0" y="0"/>
+            <a:ext cx="12191695" cy="6858000"/>
+          </a:xfrm>
+          <a:prstGeom prst="rect">
+            <a:avLst/>
+          </a:prstGeom>
+          <a:solidFill>
+            <a:srgbClr val="101317"/>
+          </a:solidFill>
+          <a:ln>
+            <a:noFill/>
+          </a:ln>
+        </p:spPr>
+        <p:style>
+          <a:lnRef idx="1">
+            <a:schemeClr val="accent1"/>
+          </a:lnRef>
+          <a:fillRef idx="3">
+            <a:schemeClr val="accent1"/>
+          </a:fillRef>
+          <a:effectRef idx="2">
+            <a:schemeClr val="accent1"/>
+          </a:effectRef>
+          <a:fontRef idx="minor">
+            <a:schemeClr val="lt1"/>
+          </a:fontRef>
+        </p:style>
+        <p:txBody>
+          <a:bodyPr rtlCol="0" anchor="ctr"/>
+          <a:lstStyle/>
+          <a:p>
+            <a:pPr algn="ctr"/>
+          </a:p>
+        </p:txBody>
+      </p:sp>
       <p:pic>
         <p:nvPicPr>
           <p:cNvPr id="3" name="Picture 2" descr="nanolang-mascot.png"/>
@@ -7948,7 +8920,7 @@
                 </a:solidFill>
                 <a:latin typeface="Courier New"/>
               </a:rPr>
-              <a:t>docs/RELEASE_4.4.md · docs/ROADMAP.md · docs/NSI_FABRIC.md</a:t>
+              <a:t>docs/RELEASE_4.5.md · userguide/guide/08_secure_runtime.md</a:t>
             </a:r>
           </a:p>
         </p:txBody>
@@ -8017,7 +8989,7 @@
                 </a:solidFill>
                 <a:latin typeface="Arial"/>
               </a:rPr>
-              <a:t>15</a:t>
+              <a:t>16</a:t>
             </a:r>
           </a:p>
         </p:txBody>

</xml_diff>